<commit_message>
Rebuild all 124 teacher decks from the current lesson HTML
Regenerated every deck in the course, not only the weeks whose lessons
changed, so the slides and the student pages no longer disagree.

The unified extractor (tools/extract_all.py) scopes sections by activity
TITLE rather than by HTML comment. The slides skill scopes on
<!-- MORPHOLOGY --> style comments, and only the Despereaux files carry
them, so everywhere else that silently returned nothing -- which is why
vocabulary came back blank. It also handles both DOL generations, four
morphology fill-in shapes, and Week 1's two-choice grammar rows.

Also removes lesson-32-3-teacher-slides-v2.pptx, a stray file that was
not part of the 124-deck set. The folder now holds exactly one deck per
daily lesson.

Co-Authored-By: Claude Opus 5 <noreply@anthropic.com>
Claude-Session: https://claude.ai/code/session_01ELfS6q5rp4zziBCnnuQgpm
</commit_message>
<xml_diff>
--- a/Planning docs/Slides/lesson-31-4-teacher-slides.pptx
+++ b/Planning docs/Slides/lesson-31-4-teacher-slides.pptx
@@ -16,10 +16,9 @@
     <p:sldId id="264" r:id="rId10"/>
     <p:sldId id="265" r:id="rId11"/>
     <p:sldId id="266" r:id="rId12"/>
-    <p:sldId id="267" r:id="rId13"/>
   </p:sldIdLst>
   <p:notesMasterIdLst>
-    <p:notesMasterId r:id="rId14"/>
+    <p:notesMasterId r:id="rId13"/>
   </p:notesMasterIdLst>
   <p:sldSz cx="9144000" cy="5143500"/>
   <p:notesSz cx="5143500" cy="9144000"/>
@@ -513,7 +512,7 @@
           <a:p>
             <a:r>
               <a:rPr lang="en-US" dirty="0"/>
-              <a:t>Title slide for Week 31 Day 4. Extension Unit.</a:t>
+              <a:t>Lesson 31.4. Reading: Reading: Week 31.</a:t>
             </a:r>
             <a:endParaRPr lang="en-US" dirty="0"/>
           </a:p>
@@ -601,7 +600,7 @@
           <a:p>
             <a:r>
               <a:rPr lang="en-US" dirty="0"/>
-              <a:t>Review morphology focus. Have students identify the base word and affix in each example.</a:t>
+              <a:t>Break the word into base + word part. Ask what the part adds to the meaning.</a:t>
             </a:r>
             <a:endParaRPr lang="en-US" dirty="0"/>
           </a:p>
@@ -689,7 +688,7 @@
           <a:p>
             <a:r>
               <a:rPr lang="en-US" dirty="0"/>
-              <a:t>Reading focus slide. Use pause-and-think questions during reading. Copywork can be done after reading.</a:t>
+              <a:t>Read the chapters, then return to the pause questions.</a:t>
             </a:r>
             <a:endParaRPr lang="en-US" dirty="0"/>
           </a:p>
@@ -713,94 +712,6 @@
             <a:fld id="{F7021451-1387-4CA6-816F-3879F97B5CBC}" type="slidenum">
               <a:rPr lang="en-US"/>
               <a:t>11</a:t>
-            </a:fld>
-            <a:endParaRPr lang="en-US"/>
-          </a:p>
-        </p:txBody>
-      </p:sp>
-    </p:spTree>
-    <p:extLst>
-      <p:ext uri="{BB962C8B-B14F-4D97-AF65-F5344CB8AC3E}">
-        <p14:creationId xmlns:p14="http://schemas.microsoft.com/office/powerpoint/2010/main" val="1024086991"/>
-      </p:ext>
-    </p:extLst>
-  </p:cSld>
-  <p:clrMapOvr>
-    <a:masterClrMapping/>
-  </p:clrMapOvr>
-</p:notes>
-</file>
-
-<file path=ppt/notesSlides/notesSlide12.xml><?xml version="1.0" encoding="utf-8"?>
-<p:notes xmlns:a="http://schemas.openxmlformats.org/drawingml/2006/main" xmlns:r="http://schemas.openxmlformats.org/officeDocument/2006/relationships" xmlns:p="http://schemas.openxmlformats.org/presentationml/2006/main">
-  <p:cSld>
-    <p:spTree>
-      <p:nvGrpSpPr>
-        <p:cNvPr id="1" name=""/>
-        <p:cNvGrpSpPr/>
-        <p:nvPr/>
-      </p:nvGrpSpPr>
-      <p:grpSpPr>
-        <a:xfrm>
-          <a:off x="0" y="0"/>
-          <a:ext cx="0" cy="0"/>
-          <a:chOff x="0" y="0"/>
-          <a:chExt cx="0" cy="0"/>
-        </a:xfrm>
-      </p:grpSpPr>
-      <p:sp>
-        <p:nvSpPr>
-          <p:cNvPr id="2" name="Slide Image Placeholder 1"/>
-          <p:cNvSpPr>
-            <a:spLocks noGrp="1" noRot="1" noChangeAspect="1"/>
-          </p:cNvSpPr>
-          <p:nvPr>
-            <p:ph type="sldImg"/>
-          </p:nvPr>
-        </p:nvSpPr>
-        <p:spPr/>
-      </p:sp>
-      <p:sp>
-        <p:nvSpPr>
-          <p:cNvPr id="3" name="Notes Placeholder 2"/>
-          <p:cNvSpPr>
-            <a:spLocks noGrp="1"/>
-          </p:cNvSpPr>
-          <p:nvPr>
-            <p:ph type="body" idx="1"/>
-          </p:nvPr>
-        </p:nvSpPr>
-        <p:spPr/>
-        <p:txBody>
-          <a:bodyPr/>
-          <a:lstStyle/>
-          <a:p>
-            <a:r>
-              <a:rPr lang="en-US" dirty="0"/>
-              <a:t>Transition to the writing workshop assignment in Canvas.</a:t>
-            </a:r>
-            <a:endParaRPr lang="en-US" dirty="0"/>
-          </a:p>
-        </p:txBody>
-      </p:sp>
-      <p:sp>
-        <p:nvSpPr>
-          <p:cNvPr id="4" name="Slide Number Placeholder 3"/>
-          <p:cNvSpPr>
-            <a:spLocks noGrp="1"/>
-          </p:cNvSpPr>
-          <p:nvPr>
-            <p:ph type="sldNum" sz="quarter" idx="10"/>
-          </p:nvPr>
-        </p:nvSpPr>
-        <p:spPr/>
-        <p:txBody>
-          <a:bodyPr/>
-          <a:lstStyle/>
-          <a:p>
-            <a:fld id="{F7021451-1387-4CA6-816F-3879F97B5CBC}" type="slidenum">
-              <a:rPr lang="en-US"/>
-              <a:t>12</a:t>
             </a:fld>
             <a:endParaRPr lang="en-US"/>
           </a:p>
@@ -865,7 +776,7 @@
           <a:p>
             <a:r>
               <a:rPr lang="en-US" dirty="0"/>
-              <a:t>Read the prompt aloud once. Give students about 1 minute to read it again silently and think. Remind them: there is no wrong answer — just write what comes to mind. Advance to the writing slide when ready.</a:t>
+              <a:t>Read the prompt aloud. Give students a moment to think before writing.</a:t>
             </a:r>
             <a:endParaRPr lang="en-US" dirty="0"/>
           </a:p>
@@ -953,7 +864,7 @@
           <a:p>
             <a:r>
               <a:rPr lang="en-US" dirty="0"/>
-              <a:t>Set a 5-minute timer. Walk the room quietly. If a student stops, gently encourage them: "Keep writing — even one more sentence." The goal is sustained writing, not perfection. Do not interrupt to correct spelling or grammar during this time.</a:t>
+              <a:t>Five minutes of sustained writing. Stamina over polish. Do not correct spelling now.</a:t>
             </a:r>
             <a:endParaRPr lang="en-US" dirty="0"/>
           </a:p>
@@ -1041,7 +952,7 @@
           <a:p>
             <a:r>
               <a:rPr lang="en-US" dirty="0"/>
-              <a:t>Set a 1-minute timer. Remind students: we are only fixing ONE thing today — Did I explain both my old thinking and my new thinking?. They should also do a quick conventions check (capitals, punctuation, spelling). They do NOT need to rewrite — just fix and improve. Revision = improving ideas; Editing = fixing conventions. Keep them separate in your language.</a:t>
+              <a:t>One fix only. Editing is conventions; revision is ideas. Name which one you are asking for.</a:t>
             </a:r>
             <a:endParaRPr lang="en-US" dirty="0"/>
           </a:p>
@@ -1129,7 +1040,7 @@
           <a:p>
             <a:r>
               <a:rPr lang="en-US" dirty="0"/>
-              <a:t>Call on 3-5 students to share. Respond with genuine interest: "I love how you described that" or "That's a really interesting idea." Avoid correcting grammar or spelling during share time — this is about celebrating writing. If time is short, have 2-3 students share in chat instead.</a:t>
+              <a:t>Two or three volunteers. Praise something specific in each.</a:t>
             </a:r>
             <a:endParaRPr lang="en-US" dirty="0"/>
           </a:p>
@@ -1217,7 +1128,7 @@
           <a:p>
             <a:r>
               <a:rPr lang="en-US" dirty="0"/>
-              <a:t>Review the big question and reading lens with students before reading.</a:t>
+              <a:t>Reading lens: Good readers in a fantasy story slow down and pay attention to how the author builds the world . Details of setting, character, and pattern all work together to create meaning.</a:t>
             </a:r>
             <a:endParaRPr lang="en-US" dirty="0"/>
           </a:p>
@@ -1305,7 +1216,8 @@
           <a:p>
             <a:r>
               <a:rPr lang="en-US" dirty="0"/>
-              <a:t>Review each grammar point with students. These are the key patterns to notice before fixing the next sentence.</a:t>
+              <a:t>Model sentence in the lesson: Both agree feeling choice lifetime.
+Tap through each highlighted word in the lesson and name what it does right before moving to the fix-it.</a:t>
             </a:r>
             <a:endParaRPr lang="en-US" dirty="0"/>
           </a:p>
@@ -1393,7 +1305,8 @@
           <a:p>
             <a:r>
               <a:rPr lang="en-US" dirty="0"/>
-              <a:t>Give students 1-2 minutes to fix the sentence. Walk the room and check.</a:t>
+              <a:t>Corrected: Corrected: After reading both texts, I believe that courage is something every character we read about this year had to find inside themselves. 
+Look for: After reading both texts begins the dependent clause; comma after texts; I is always capitalized; period ends.</a:t>
             </a:r>
             <a:endParaRPr lang="en-US" dirty="0"/>
           </a:p>
@@ -1481,7 +1394,8 @@
           <a:p>
             <a:r>
               <a:rPr lang="en-US" dirty="0"/>
-              <a:t>Reveal the corrected version. Point out each fix: capitalization, punctuation, spelling.</a:t>
+              <a:t>Corrected: Corrected: After reading both texts, I believe that courage is something every character we read about this year had to find inside themselves. 
+Look for: After reading both texts begins the dependent clause; comma after texts; I is always capitalized; period ends.</a:t>
             </a:r>
             <a:endParaRPr lang="en-US" dirty="0"/>
           </a:p>
@@ -1836,7 +1750,7 @@
     <p:bg>
       <p:bgPr>
         <a:solidFill>
-          <a:srgbClr val="2C3E50"/>
+          <a:srgbClr val="0E1C42"/>
         </a:solidFill>
       </p:bgPr>
     </p:bg>
@@ -1862,8 +1776,8 @@
         </p:nvSpPr>
         <p:spPr>
           <a:xfrm>
-            <a:off x="457200" y="914400"/>
-            <a:ext cx="8229600" cy="1097280"/>
+            <a:off x="0" y="822960"/>
+            <a:ext cx="9144000" cy="822960"/>
           </a:xfrm>
           <a:prstGeom prst="rect">
             <a:avLst/>
@@ -1879,7 +1793,43 @@
               <a:buNone/>
             </a:pPr>
             <a:r>
-              <a:rPr lang="en-US" sz="4000" b="1" dirty="0">
+              <a:rPr lang="en-US" sz="5200" dirty="0">
+                <a:solidFill>
+                  <a:srgbClr val="000000"/>
+                </a:solidFill>
+              </a:rPr>
+              <a:t>🎉</a:t>
+            </a:r>
+            <a:endParaRPr lang="en-US" sz="5200" dirty="0"/>
+          </a:p>
+        </p:txBody>
+      </p:sp>
+      <p:sp>
+        <p:nvSpPr>
+          <p:cNvPr id="3" name="Text 1"/>
+          <p:cNvSpPr/>
+          <p:nvPr/>
+        </p:nvSpPr>
+        <p:spPr>
+          <a:xfrm>
+            <a:off x="457200" y="1691640"/>
+            <a:ext cx="8229600" cy="566928"/>
+          </a:xfrm>
+          <a:prstGeom prst="rect">
+            <a:avLst/>
+          </a:prstGeom>
+          <a:noFill/>
+          <a:ln/>
+        </p:spPr>
+        <p:txBody>
+          <a:bodyPr wrap="square" lIns="0" tIns="0" rIns="0" bIns="0" rtlCol="0" anchor="ctr"/>
+          <a:lstStyle/>
+          <a:p>
+            <a:pPr algn="ctr" indent="0" marL="0">
+              <a:buNone/>
+            </a:pPr>
+            <a:r>
+              <a:rPr lang="en-US" sz="3400" b="1" dirty="0">
                 <a:solidFill>
                   <a:srgbClr val="FFFFFF"/>
                 </a:solidFill>
@@ -1887,22 +1837,22 @@
                 <a:ea typeface="Calibri" pitchFamily="34" charset="-122"/>
                 <a:cs typeface="Calibri" pitchFamily="34" charset="-120"/>
               </a:rPr>
-              <a:t>🌟  Week 31 · Day 4</a:t>
-            </a:r>
-            <a:endParaRPr lang="en-US" sz="4000" dirty="0"/>
-          </a:p>
-        </p:txBody>
-      </p:sp>
-      <p:sp>
-        <p:nvSpPr>
-          <p:cNvPr id="3" name="Text 1"/>
-          <p:cNvSpPr/>
-          <p:nvPr/>
-        </p:nvSpPr>
-        <p:spPr>
-          <a:xfrm>
-            <a:off x="457200" y="2103120"/>
-            <a:ext cx="8229600" cy="731520"/>
+              <a:t>Year-End Synthesis</a:t>
+            </a:r>
+            <a:endParaRPr lang="en-US" sz="3400" dirty="0"/>
+          </a:p>
+        </p:txBody>
+      </p:sp>
+      <p:sp>
+        <p:nvSpPr>
+          <p:cNvPr id="4" name="Text 2"/>
+          <p:cNvSpPr/>
+          <p:nvPr/>
+        </p:nvSpPr>
+        <p:spPr>
+          <a:xfrm>
+            <a:off x="457200" y="2331720"/>
+            <a:ext cx="8229600" cy="411480"/>
           </a:xfrm>
           <a:prstGeom prst="rect">
             <a:avLst/>
@@ -1918,30 +1868,30 @@
               <a:buNone/>
             </a:pPr>
             <a:r>
-              <a:rPr lang="en-US" sz="1800" dirty="0">
-                <a:solidFill>
-                  <a:srgbClr val="E67E22"/>
-                </a:solidFill>
-                <a:latin typeface="Calibri" pitchFamily="34" charset="0"/>
-                <a:ea typeface="Calibri" pitchFamily="34" charset="-122"/>
-                <a:cs typeface="Calibri" pitchFamily="34" charset="-120"/>
-              </a:rPr>
-              <a:t>Extension Unit — Lesson 31.4</a:t>
-            </a:r>
-            <a:endParaRPr lang="en-US" sz="1800" dirty="0"/>
-          </a:p>
-        </p:txBody>
-      </p:sp>
-      <p:sp>
-        <p:nvSpPr>
-          <p:cNvPr id="4" name="Text 2"/>
-          <p:cNvSpPr/>
-          <p:nvPr/>
-        </p:nvSpPr>
-        <p:spPr>
-          <a:xfrm>
-            <a:off x="457200" y="4114800"/>
-            <a:ext cx="8229600" cy="457200"/>
+              <a:rPr lang="en-US" sz="2000" dirty="0">
+                <a:solidFill>
+                  <a:srgbClr val="34B76F"/>
+                </a:solidFill>
+                <a:latin typeface="Calibri" pitchFamily="34" charset="0"/>
+                <a:ea typeface="Calibri" pitchFamily="34" charset="-122"/>
+                <a:cs typeface="Calibri" pitchFamily="34" charset="-120"/>
+              </a:rPr>
+              <a:t>Lesson 31.4  ·  Reading: Week 31</a:t>
+            </a:r>
+            <a:endParaRPr lang="en-US" sz="2000" dirty="0"/>
+          </a:p>
+        </p:txBody>
+      </p:sp>
+      <p:sp>
+        <p:nvSpPr>
+          <p:cNvPr id="5" name="Text 3"/>
+          <p:cNvSpPr/>
+          <p:nvPr/>
+        </p:nvSpPr>
+        <p:spPr>
+          <a:xfrm>
+            <a:off x="457200" y="2880360"/>
+            <a:ext cx="8229600" cy="320040"/>
           </a:xfrm>
           <a:prstGeom prst="rect">
             <a:avLst/>
@@ -1957,17 +1907,17 @@
               <a:buNone/>
             </a:pPr>
             <a:r>
-              <a:rPr lang="en-US" sz="1300" dirty="0">
-                <a:solidFill>
-                  <a:srgbClr val="AAAAAA"/>
-                </a:solidFill>
-                <a:latin typeface="Calibri" pitchFamily="34" charset="0"/>
-                <a:ea typeface="Calibri" pitchFamily="34" charset="-122"/>
-                <a:cs typeface="Calibri" pitchFamily="34" charset="-120"/>
-              </a:rPr>
-              <a:t>Optima Academy Online · 3rd Grade ELA</a:t>
-            </a:r>
-            <a:endParaRPr lang="en-US" sz="1300" dirty="0"/>
+              <a:rPr lang="en-US" sz="1400" dirty="0">
+                <a:solidFill>
+                  <a:srgbClr val="C9BCE4"/>
+                </a:solidFill>
+                <a:latin typeface="Calibri" pitchFamily="34" charset="0"/>
+                <a:ea typeface="Calibri" pitchFamily="34" charset="-122"/>
+                <a:cs typeface="Calibri" pitchFamily="34" charset="-120"/>
+              </a:rPr>
+              <a:t>Grade 3 ELA  ·  Virtue: Gratitude</a:t>
+            </a:r>
+            <a:endParaRPr lang="en-US" sz="1400" dirty="0"/>
           </a:p>
         </p:txBody>
       </p:sp>
@@ -2005,14 +1955,34 @@
       </p:grpSpPr>
       <p:sp>
         <p:nvSpPr>
-          <p:cNvPr id="2" name="Text 0"/>
-          <p:cNvSpPr/>
-          <p:nvPr/>
-        </p:nvSpPr>
-        <p:spPr>
-          <a:xfrm>
-            <a:off x="365760" y="164592"/>
-            <a:ext cx="8412480" cy="566928"/>
+          <p:cNvPr id="2" name="Shape 0"/>
+          <p:cNvSpPr/>
+          <p:nvPr/>
+        </p:nvSpPr>
+        <p:spPr>
+          <a:xfrm>
+            <a:off x="0" y="0"/>
+            <a:ext cx="9144000" cy="566928"/>
+          </a:xfrm>
+          <a:prstGeom prst="rect">
+            <a:avLst/>
+          </a:prstGeom>
+          <a:solidFill>
+            <a:srgbClr val="34B76F"/>
+          </a:solidFill>
+          <a:ln/>
+        </p:spPr>
+      </p:sp>
+      <p:sp>
+        <p:nvSpPr>
+          <p:cNvPr id="3" name="Text 1"/>
+          <p:cNvSpPr/>
+          <p:nvPr/>
+        </p:nvSpPr>
+        <p:spPr>
+          <a:xfrm>
+            <a:off x="365760" y="54864"/>
+            <a:ext cx="8412480" cy="457200"/>
           </a:xfrm>
           <a:prstGeom prst="rect">
             <a:avLst/>
@@ -2024,46 +1994,23 @@
           <a:bodyPr wrap="square" lIns="0" tIns="0" rIns="0" bIns="0" rtlCol="0" anchor="ctr"/>
           <a:lstStyle/>
           <a:p>
-            <a:pPr algn="l" indent="0" marL="0">
-              <a:buNone/>
-            </a:pPr>
-            <a:r>
-              <a:rPr lang="en-US" sz="2800" b="1" dirty="0">
-                <a:solidFill>
-                  <a:srgbClr val="0E1C42"/>
-                </a:solidFill>
-                <a:latin typeface="Calibri" pitchFamily="34" charset="0"/>
-                <a:ea typeface="Calibri" pitchFamily="34" charset="-122"/>
-                <a:cs typeface="Calibri" pitchFamily="34" charset="-120"/>
-              </a:rPr>
-              <a:t>🌱 Morphology: Morphology review: prefixes and suffixes</a:t>
-            </a:r>
-            <a:endParaRPr lang="en-US" sz="2800" dirty="0"/>
-          </a:p>
-        </p:txBody>
-      </p:sp>
-      <p:sp>
-        <p:nvSpPr>
-          <p:cNvPr id="3" name="Shape 1"/>
-          <p:cNvSpPr/>
-          <p:nvPr/>
-        </p:nvSpPr>
-        <p:spPr>
-          <a:xfrm>
-            <a:off x="365760" y="749808"/>
-            <a:ext cx="8412480" cy="0"/>
-          </a:xfrm>
-          <a:prstGeom prst="line">
-            <a:avLst/>
-          </a:prstGeom>
-          <a:noFill/>
-          <a:ln w="19050">
-            <a:solidFill>
-              <a:srgbClr val="8B6FC0"/>
-            </a:solidFill>
-            <a:prstDash val="solid"/>
-          </a:ln>
-        </p:spPr>
+            <a:pPr indent="0" marL="0">
+              <a:buNone/>
+            </a:pPr>
+            <a:r>
+              <a:rPr lang="en-US" sz="2200" b="1" dirty="0">
+                <a:solidFill>
+                  <a:srgbClr val="FFFFFF"/>
+                </a:solidFill>
+                <a:latin typeface="Calibri" pitchFamily="34" charset="0"/>
+                <a:ea typeface="Calibri" pitchFamily="34" charset="-122"/>
+                <a:cs typeface="Calibri" pitchFamily="34" charset="-120"/>
+              </a:rPr>
+              <a:t>🌱  Morphology</a:t>
+            </a:r>
+            <a:endParaRPr lang="en-US" sz="2200" dirty="0"/>
+          </a:p>
+        </p:txBody>
       </p:sp>
       <p:sp>
         <p:nvSpPr>
@@ -2073,8 +2020,8 @@
         </p:nvSpPr>
         <p:spPr>
           <a:xfrm>
-            <a:off x="457200" y="1005840"/>
-            <a:ext cx="8046720" cy="292608"/>
+            <a:off x="365760" y="804672"/>
+            <a:ext cx="8229600" cy="237744"/>
           </a:xfrm>
           <a:prstGeom prst="rect">
             <a:avLst/>
@@ -2090,15 +2037,15 @@
               <a:buNone/>
             </a:pPr>
             <a:r>
-              <a:rPr lang="en-US" sz="1100" b="1" spc="200" kern="0" dirty="0">
-                <a:solidFill>
-                  <a:srgbClr val="64748B"/>
-                </a:solidFill>
-                <a:latin typeface="Calibri" pitchFamily="34" charset="0"/>
-                <a:ea typeface="Calibri" pitchFamily="34" charset="-122"/>
-                <a:cs typeface="Calibri" pitchFamily="34" charset="-120"/>
-              </a:rPr>
-              <a:t>CONCEPT EXAMPLES</a:t>
+              <a:rPr lang="en-US" sz="1100" b="1" spc="100" kern="0" dirty="0">
+                <a:solidFill>
+                  <a:srgbClr val="8B6FC0"/>
+                </a:solidFill>
+                <a:latin typeface="Calibri" pitchFamily="34" charset="0"/>
+                <a:ea typeface="Calibri" pitchFamily="34" charset="-122"/>
+                <a:cs typeface="Calibri" pitchFamily="34" charset="-120"/>
+              </a:rPr>
+              <a:t>MORPHOLOGY REVIEW: PREFIXES AND SUFFIXES</a:t>
             </a:r>
             <a:endParaRPr lang="en-US" sz="1100" dirty="0"/>
           </a:p>
@@ -2106,14 +2053,43 @@
       </p:sp>
       <p:sp>
         <p:nvSpPr>
-          <p:cNvPr id="5" name="Text 3"/>
-          <p:cNvSpPr/>
-          <p:nvPr/>
-        </p:nvSpPr>
-        <p:spPr>
-          <a:xfrm>
-            <a:off x="640080" y="1325880"/>
-            <a:ext cx="7863840" cy="320040"/>
+          <p:cNvPr id="5" name="Shape 3"/>
+          <p:cNvSpPr/>
+          <p:nvPr/>
+        </p:nvSpPr>
+        <p:spPr>
+          <a:xfrm>
+            <a:off x="365760" y="1097280"/>
+            <a:ext cx="8412480" cy="621792"/>
+          </a:xfrm>
+          <a:prstGeom prst="roundRect">
+            <a:avLst>
+              <a:gd name="adj" fmla="val 14706"/>
+            </a:avLst>
+          </a:prstGeom>
+          <a:solidFill>
+            <a:srgbClr val="F0E8FF"/>
+          </a:solidFill>
+          <a:ln/>
+          <a:effectLst>
+            <a:outerShdw sx="100000" sy="100000" kx="0" ky="0" algn="bl" rotWithShape="0" blurRad="101600" dist="38100" dir="2700000">
+              <a:srgbClr val="000000">
+                <a:alpha val="12000"/>
+              </a:srgbClr>
+            </a:outerShdw>
+          </a:effectLst>
+        </p:spPr>
+      </p:sp>
+      <p:sp>
+        <p:nvSpPr>
+          <p:cNvPr id="6" name="Text 4"/>
+          <p:cNvSpPr/>
+          <p:nvPr/>
+        </p:nvSpPr>
+        <p:spPr>
+          <a:xfrm>
+            <a:off x="594360" y="1216152"/>
+            <a:ext cx="7863840" cy="384048"/>
           </a:xfrm>
           <a:prstGeom prst="rect">
             <a:avLst/>
@@ -2129,7 +2105,7 @@
               <a:buNone/>
             </a:pPr>
             <a:r>
-              <a:rPr lang="en-US" sz="1300" dirty="0">
+              <a:rPr lang="en-US" sz="1500" dirty="0">
                 <a:solidFill>
                   <a:srgbClr val="1E293B"/>
                 </a:solidFill>
@@ -2137,9 +2113,9 @@
                 <a:ea typeface="Calibri" pitchFamily="34" charset="-122"/>
                 <a:cs typeface="Calibri" pitchFamily="34" charset="-120"/>
               </a:rPr>
-              <a:t>• 📌 Explain: What does Review mean?</a:t>
-            </a:r>
-            <a:endParaRPr lang="en-US" sz="1300" dirty="0"/>
+              <a:t>🌱  Complete each sentence in your notebook to show you understand the word part.</a:t>
+            </a:r>
+            <a:endParaRPr lang="en-US" sz="1500" dirty="0"/>
           </a:p>
         </p:txBody>
       </p:sp>
@@ -2177,14 +2153,34 @@
       </p:grpSpPr>
       <p:sp>
         <p:nvSpPr>
-          <p:cNvPr id="2" name="Text 0"/>
-          <p:cNvSpPr/>
-          <p:nvPr/>
-        </p:nvSpPr>
-        <p:spPr>
-          <a:xfrm>
-            <a:off x="365760" y="164592"/>
-            <a:ext cx="8412480" cy="566928"/>
+          <p:cNvPr id="2" name="Shape 0"/>
+          <p:cNvSpPr/>
+          <p:nvPr/>
+        </p:nvSpPr>
+        <p:spPr>
+          <a:xfrm>
+            <a:off x="0" y="0"/>
+            <a:ext cx="9144000" cy="566928"/>
+          </a:xfrm>
+          <a:prstGeom prst="rect">
+            <a:avLst/>
+          </a:prstGeom>
+          <a:solidFill>
+            <a:srgbClr val="34B76F"/>
+          </a:solidFill>
+          <a:ln/>
+        </p:spPr>
+      </p:sp>
+      <p:sp>
+        <p:nvSpPr>
+          <p:cNvPr id="3" name="Text 1"/>
+          <p:cNvSpPr/>
+          <p:nvPr/>
+        </p:nvSpPr>
+        <p:spPr>
+          <a:xfrm>
+            <a:off x="365760" y="54864"/>
+            <a:ext cx="8412480" cy="457200"/>
           </a:xfrm>
           <a:prstGeom prst="rect">
             <a:avLst/>
@@ -2196,11 +2192,50 @@
           <a:bodyPr wrap="square" lIns="0" tIns="0" rIns="0" bIns="0" rtlCol="0" anchor="ctr"/>
           <a:lstStyle/>
           <a:p>
-            <a:pPr algn="l" indent="0" marL="0">
-              <a:buNone/>
-            </a:pPr>
-            <a:r>
-              <a:rPr lang="en-US" sz="2800" b="1" dirty="0">
+            <a:pPr indent="0" marL="0">
+              <a:buNone/>
+            </a:pPr>
+            <a:r>
+              <a:rPr lang="en-US" sz="2200" b="1" dirty="0">
+                <a:solidFill>
+                  <a:srgbClr val="FFFFFF"/>
+                </a:solidFill>
+                <a:latin typeface="Calibri" pitchFamily="34" charset="0"/>
+                <a:ea typeface="Calibri" pitchFamily="34" charset="-122"/>
+                <a:cs typeface="Calibri" pitchFamily="34" charset="-120"/>
+              </a:rPr>
+              <a:t>📕  Read</a:t>
+            </a:r>
+            <a:endParaRPr lang="en-US" sz="2200" dirty="0"/>
+          </a:p>
+        </p:txBody>
+      </p:sp>
+      <p:sp>
+        <p:nvSpPr>
+          <p:cNvPr id="4" name="Text 2"/>
+          <p:cNvSpPr/>
+          <p:nvPr/>
+        </p:nvSpPr>
+        <p:spPr>
+          <a:xfrm>
+            <a:off x="365760" y="868680"/>
+            <a:ext cx="8412480" cy="502920"/>
+          </a:xfrm>
+          <a:prstGeom prst="rect">
+            <a:avLst/>
+          </a:prstGeom>
+          <a:noFill/>
+          <a:ln/>
+        </p:spPr>
+        <p:txBody>
+          <a:bodyPr wrap="square" lIns="0" tIns="0" rIns="0" bIns="0" rtlCol="0" anchor="ctr"/>
+          <a:lstStyle/>
+          <a:p>
+            <a:pPr indent="0" marL="0">
+              <a:buNone/>
+            </a:pPr>
+            <a:r>
+              <a:rPr lang="en-US" sz="2600" b="1" dirty="0">
                 <a:solidFill>
                   <a:srgbClr val="0E1C42"/>
                 </a:solidFill>
@@ -2210,43 +2245,20 @@
               </a:rPr>
               <a:t>Reading: Week 31</a:t>
             </a:r>
-            <a:endParaRPr lang="en-US" sz="2800" dirty="0"/>
-          </a:p>
-        </p:txBody>
-      </p:sp>
-      <p:sp>
-        <p:nvSpPr>
-          <p:cNvPr id="3" name="Shape 1"/>
-          <p:cNvSpPr/>
-          <p:nvPr/>
-        </p:nvSpPr>
-        <p:spPr>
-          <a:xfrm>
-            <a:off x="365760" y="749808"/>
-            <a:ext cx="8412480" cy="0"/>
-          </a:xfrm>
-          <a:prstGeom prst="line">
-            <a:avLst/>
-          </a:prstGeom>
-          <a:noFill/>
-          <a:ln w="19050">
-            <a:solidFill>
-              <a:srgbClr val="55C8E8"/>
-            </a:solidFill>
-            <a:prstDash val="solid"/>
-          </a:ln>
-        </p:spPr>
-      </p:sp>
-      <p:sp>
-        <p:nvSpPr>
-          <p:cNvPr id="4" name="Text 2"/>
-          <p:cNvSpPr/>
-          <p:nvPr/>
-        </p:nvSpPr>
-        <p:spPr>
-          <a:xfrm>
-            <a:off x="457200" y="1005840"/>
-            <a:ext cx="8046720" cy="292608"/>
+            <a:endParaRPr lang="en-US" sz="2600" dirty="0"/>
+          </a:p>
+        </p:txBody>
+      </p:sp>
+      <p:sp>
+        <p:nvSpPr>
+          <p:cNvPr id="5" name="Text 3"/>
+          <p:cNvSpPr/>
+          <p:nvPr/>
+        </p:nvSpPr>
+        <p:spPr>
+          <a:xfrm>
+            <a:off x="365760" y="1463040"/>
+            <a:ext cx="8229600" cy="237744"/>
           </a:xfrm>
           <a:prstGeom prst="rect">
             <a:avLst/>
@@ -2262,9 +2274,9 @@
               <a:buNone/>
             </a:pPr>
             <a:r>
-              <a:rPr lang="en-US" sz="1100" b="1" spc="200" kern="0" dirty="0">
-                <a:solidFill>
-                  <a:srgbClr val="55C8E8"/>
+              <a:rPr lang="en-US" sz="1100" b="1" spc="100" kern="0" dirty="0">
+                <a:solidFill>
+                  <a:srgbClr val="C7922C"/>
                 </a:solidFill>
                 <a:latin typeface="Calibri" pitchFamily="34" charset="0"/>
                 <a:ea typeface="Calibri" pitchFamily="34" charset="-122"/>
@@ -2278,14 +2290,14 @@
       </p:sp>
       <p:sp>
         <p:nvSpPr>
-          <p:cNvPr id="5" name="Text 3"/>
-          <p:cNvSpPr/>
-          <p:nvPr/>
-        </p:nvSpPr>
-        <p:spPr>
-          <a:xfrm>
-            <a:off x="640080" y="1325880"/>
-            <a:ext cx="7863840" cy="548640"/>
+          <p:cNvPr id="6" name="Text 4"/>
+          <p:cNvSpPr/>
+          <p:nvPr/>
+        </p:nvSpPr>
+        <p:spPr>
+          <a:xfrm>
+            <a:off x="365760" y="1719072"/>
+            <a:ext cx="8412480" cy="914400"/>
           </a:xfrm>
           <a:prstGeom prst="rect">
             <a:avLst/>
@@ -2301,7 +2313,7 @@
               <a:buNone/>
             </a:pPr>
             <a:r>
-              <a:rPr lang="en-US" sz="1400" i="1" dirty="0">
+              <a:rPr lang="en-US" sz="1500" dirty="0">
                 <a:solidFill>
                   <a:srgbClr val="1E293B"/>
                 </a:solidFill>
@@ -2309,38 +2321,16 @@
                 <a:ea typeface="Calibri" pitchFamily="34" charset="-122"/>
                 <a:cs typeface="Calibri" pitchFamily="34" charset="-120"/>
               </a:rPr>
-              <a:t>As you read today, ask yourself: After a whole year of reading, what do you think courage really means — and which story taught you the most about it?</a:t>
-            </a:r>
-            <a:endParaRPr lang="en-US" sz="1400" dirty="0"/>
-          </a:p>
-        </p:txBody>
-      </p:sp>
-      <p:sp>
-        <p:nvSpPr>
-          <p:cNvPr id="6" name="Text 4"/>
-          <p:cNvSpPr/>
-          <p:nvPr/>
-        </p:nvSpPr>
-        <p:spPr>
-          <a:xfrm>
-            <a:off x="640080" y="1965960"/>
-            <a:ext cx="7863840" cy="548640"/>
-          </a:xfrm>
-          <a:prstGeom prst="rect">
-            <a:avLst/>
-          </a:prstGeom>
-          <a:noFill/>
-          <a:ln/>
-        </p:spPr>
-        <p:txBody>
-          <a:bodyPr wrap="square" lIns="0" tIns="0" rIns="0" bIns="0" rtlCol="0" anchor="ctr"/>
-          <a:lstStyle/>
-          <a:p>
-            <a:pPr indent="0" marL="0">
-              <a:buNone/>
-            </a:pPr>
-            <a:r>
-              <a:rPr lang="en-US" sz="1400" i="1" dirty="0">
+              <a:t>•  Compare how two authors present the same topic or theme.</a:t>
+            </a:r>
+            <a:endParaRPr lang="en-US" sz="1500" dirty="0"/>
+          </a:p>
+          <a:p>
+            <a:pPr indent="0" marL="0">
+              <a:buNone/>
+            </a:pPr>
+            <a:r>
+              <a:rPr lang="en-US" sz="1500" dirty="0">
                 <a:solidFill>
                   <a:srgbClr val="1E293B"/>
                 </a:solidFill>
@@ -2348,132 +2338,16 @@
                 <a:ea typeface="Calibri" pitchFamily="34" charset="-122"/>
                 <a:cs typeface="Calibri" pitchFamily="34" charset="-120"/>
               </a:rPr>
-              <a:t>Write your closing paragraph. Restate your claim about courage in a new way, and explain what you take away from reading both texts.</a:t>
-            </a:r>
-            <a:endParaRPr lang="en-US" sz="1400" dirty="0"/>
-          </a:p>
-        </p:txBody>
-      </p:sp>
-    </p:spTree>
-  </p:cSld>
-  <p:clrMapOvr>
-    <a:masterClrMapping/>
-  </p:clrMapOvr>
-</p:sld>
-</file>
-
-<file path=ppt/slides/slide12.xml><?xml version="1.0" encoding="utf-8"?>
-<p:sld xmlns:a="http://schemas.openxmlformats.org/drawingml/2006/main" xmlns:r="http://schemas.openxmlformats.org/officeDocument/2006/relationships" xmlns:p="http://schemas.openxmlformats.org/presentationml/2006/main">
-  <p:cSld name="Slide 12">
-    <p:bg>
-      <p:bgPr>
-        <a:solidFill>
-          <a:srgbClr val="FFFFFF"/>
-        </a:solidFill>
-      </p:bgPr>
-    </p:bg>
-    <p:spTree>
-      <p:nvGrpSpPr>
-        <p:cNvPr id="1" name=""/>
-        <p:cNvGrpSpPr/>
-        <p:nvPr/>
-      </p:nvGrpSpPr>
-      <p:grpSpPr>
-        <a:xfrm>
-          <a:off x="0" y="0"/>
-          <a:ext cx="0" cy="0"/>
-          <a:chOff x="0" y="0"/>
-          <a:chExt cx="0" cy="0"/>
-        </a:xfrm>
-      </p:grpSpPr>
-      <p:sp>
-        <p:nvSpPr>
-          <p:cNvPr id="2" name="Text 0"/>
-          <p:cNvSpPr/>
-          <p:nvPr/>
-        </p:nvSpPr>
-        <p:spPr>
-          <a:xfrm>
-            <a:off x="365760" y="164592"/>
-            <a:ext cx="8412480" cy="566928"/>
-          </a:xfrm>
-          <a:prstGeom prst="rect">
-            <a:avLst/>
-          </a:prstGeom>
-          <a:noFill/>
-          <a:ln/>
-        </p:spPr>
-        <p:txBody>
-          <a:bodyPr wrap="square" lIns="0" tIns="0" rIns="0" bIns="0" rtlCol="0" anchor="ctr"/>
-          <a:lstStyle/>
-          <a:p>
-            <a:pPr algn="l" indent="0" marL="0">
-              <a:buNone/>
-            </a:pPr>
-            <a:r>
-              <a:rPr lang="en-US" sz="2800" b="1" dirty="0">
-                <a:solidFill>
-                  <a:srgbClr val="0E1C42"/>
-                </a:solidFill>
-                <a:latin typeface="Calibri" pitchFamily="34" charset="0"/>
-                <a:ea typeface="Calibri" pitchFamily="34" charset="-122"/>
-                <a:cs typeface="Calibri" pitchFamily="34" charset="-120"/>
-              </a:rPr>
-              <a:t>Writer’s Workshop: Week 31 · COMPLETE Comparison Response</a:t>
-            </a:r>
-            <a:endParaRPr lang="en-US" sz="2800" dirty="0"/>
-          </a:p>
-        </p:txBody>
-      </p:sp>
-      <p:sp>
-        <p:nvSpPr>
-          <p:cNvPr id="3" name="Shape 1"/>
-          <p:cNvSpPr/>
-          <p:nvPr/>
-        </p:nvSpPr>
-        <p:spPr>
-          <a:xfrm>
-            <a:off x="365760" y="749808"/>
-            <a:ext cx="8412480" cy="0"/>
-          </a:xfrm>
-          <a:prstGeom prst="line">
-            <a:avLst/>
-          </a:prstGeom>
-          <a:noFill/>
-          <a:ln w="19050">
-            <a:solidFill>
-              <a:srgbClr val="34B76F"/>
-            </a:solidFill>
-            <a:prstDash val="solid"/>
-          </a:ln>
-        </p:spPr>
-      </p:sp>
-      <p:sp>
-        <p:nvSpPr>
-          <p:cNvPr id="4" name="Text 2"/>
-          <p:cNvSpPr/>
-          <p:nvPr/>
-        </p:nvSpPr>
-        <p:spPr>
-          <a:xfrm>
-            <a:off x="640080" y="1371600"/>
-            <a:ext cx="7863840" cy="457200"/>
-          </a:xfrm>
-          <a:prstGeom prst="rect">
-            <a:avLst/>
-          </a:prstGeom>
-          <a:noFill/>
-          <a:ln/>
-        </p:spPr>
-        <p:txBody>
-          <a:bodyPr wrap="square" lIns="0" tIns="0" rIns="0" bIns="0" rtlCol="0" anchor="ctr"/>
-          <a:lstStyle/>
-          <a:p>
-            <a:pPr indent="0" marL="0">
-              <a:buNone/>
-            </a:pPr>
-            <a:r>
-              <a:rPr lang="en-US" sz="1600" dirty="0">
+              <a:t>•  As you read today, ask yourself: After a whole year of reading, what do you think courage really means — and which story taught you the most about it?</a:t>
+            </a:r>
+            <a:endParaRPr lang="en-US" sz="1500" dirty="0"/>
+          </a:p>
+          <a:p>
+            <a:pPr indent="0" marL="0">
+              <a:buNone/>
+            </a:pPr>
+            <a:r>
+              <a:rPr lang="en-US" sz="1500" dirty="0">
                 <a:solidFill>
                   <a:srgbClr val="1E293B"/>
                 </a:solidFill>
@@ -2481,48 +2355,9 @@
                 <a:ea typeface="Calibri" pitchFamily="34" charset="-122"/>
                 <a:cs typeface="Calibri" pitchFamily="34" charset="-120"/>
               </a:rPr>
-              <a:t>Open your writing assignment in Canvas.</a:t>
-            </a:r>
-            <a:endParaRPr lang="en-US" sz="1600" dirty="0"/>
-          </a:p>
-        </p:txBody>
-      </p:sp>
-      <p:sp>
-        <p:nvSpPr>
-          <p:cNvPr id="5" name="Text 3"/>
-          <p:cNvSpPr/>
-          <p:nvPr/>
-        </p:nvSpPr>
-        <p:spPr>
-          <a:xfrm>
-            <a:off x="640080" y="2011680"/>
-            <a:ext cx="7863840" cy="457200"/>
-          </a:xfrm>
-          <a:prstGeom prst="rect">
-            <a:avLst/>
-          </a:prstGeom>
-          <a:noFill/>
-          <a:ln/>
-        </p:spPr>
-        <p:txBody>
-          <a:bodyPr wrap="square" lIns="0" tIns="0" rIns="0" bIns="0" rtlCol="0" anchor="ctr"/>
-          <a:lstStyle/>
-          <a:p>
-            <a:pPr indent="0" marL="0">
-              <a:buNone/>
-            </a:pPr>
-            <a:r>
-              <a:rPr lang="en-US" sz="1400" dirty="0">
-                <a:solidFill>
-                  <a:srgbClr val="64748B"/>
-                </a:solidFill>
-                <a:latin typeface="Calibri" pitchFamily="34" charset="0"/>
-                <a:ea typeface="Calibri" pitchFamily="34" charset="-122"/>
-                <a:cs typeface="Calibri" pitchFamily="34" charset="-120"/>
-              </a:rPr>
-              <a:t>Follow the writing prompt for today's workshop.</a:t>
-            </a:r>
-            <a:endParaRPr lang="en-US" sz="1400" dirty="0"/>
+              <a:t>•  Write your poem in your journal. Then write one sentence underneath naming the form you chose and the figurative language you used.</a:t>
+            </a:r>
+            <a:endParaRPr lang="en-US" sz="1500" dirty="0"/>
           </a:p>
         </p:txBody>
       </p:sp>
@@ -2560,14 +2395,34 @@
       </p:grpSpPr>
       <p:sp>
         <p:nvSpPr>
-          <p:cNvPr id="2" name="Text 0"/>
-          <p:cNvSpPr/>
-          <p:nvPr/>
-        </p:nvSpPr>
-        <p:spPr>
-          <a:xfrm>
-            <a:off x="365760" y="164592"/>
-            <a:ext cx="8412480" cy="566928"/>
+          <p:cNvPr id="2" name="Shape 0"/>
+          <p:cNvSpPr/>
+          <p:nvPr/>
+        </p:nvSpPr>
+        <p:spPr>
+          <a:xfrm>
+            <a:off x="0" y="0"/>
+            <a:ext cx="9144000" cy="566928"/>
+          </a:xfrm>
+          <a:prstGeom prst="rect">
+            <a:avLst/>
+          </a:prstGeom>
+          <a:solidFill>
+            <a:srgbClr val="C7922C"/>
+          </a:solidFill>
+          <a:ln/>
+        </p:spPr>
+      </p:sp>
+      <p:sp>
+        <p:nvSpPr>
+          <p:cNvPr id="3" name="Text 1"/>
+          <p:cNvSpPr/>
+          <p:nvPr/>
+        </p:nvSpPr>
+        <p:spPr>
+          <a:xfrm>
+            <a:off x="365760" y="54864"/>
+            <a:ext cx="8412480" cy="457200"/>
           </a:xfrm>
           <a:prstGeom prst="rect">
             <a:avLst/>
@@ -2579,46 +2434,23 @@
           <a:bodyPr wrap="square" lIns="0" tIns="0" rIns="0" bIns="0" rtlCol="0" anchor="ctr"/>
           <a:lstStyle/>
           <a:p>
-            <a:pPr algn="l" indent="0" marL="0">
-              <a:buNone/>
-            </a:pPr>
-            <a:r>
-              <a:rPr lang="en-US" sz="2800" b="1" dirty="0">
-                <a:solidFill>
-                  <a:srgbClr val="0E1C42"/>
-                </a:solidFill>
-                <a:latin typeface="Calibri" pitchFamily="34" charset="0"/>
-                <a:ea typeface="Calibri" pitchFamily="34" charset="-122"/>
-                <a:cs typeface="Calibri" pitchFamily="34" charset="-120"/>
-              </a:rPr>
-              <a:t>✏️ 10-Minute Write</a:t>
-            </a:r>
-            <a:endParaRPr lang="en-US" sz="2800" dirty="0"/>
-          </a:p>
-        </p:txBody>
-      </p:sp>
-      <p:sp>
-        <p:nvSpPr>
-          <p:cNvPr id="3" name="Shape 1"/>
-          <p:cNvSpPr/>
-          <p:nvPr/>
-        </p:nvSpPr>
-        <p:spPr>
-          <a:xfrm>
-            <a:off x="365760" y="749808"/>
-            <a:ext cx="8412480" cy="0"/>
-          </a:xfrm>
-          <a:prstGeom prst="line">
-            <a:avLst/>
-          </a:prstGeom>
-          <a:noFill/>
-          <a:ln w="19050">
-            <a:solidFill>
-              <a:srgbClr val="C7922C"/>
-            </a:solidFill>
-            <a:prstDash val="solid"/>
-          </a:ln>
-        </p:spPr>
+            <a:pPr indent="0" marL="0">
+              <a:buNone/>
+            </a:pPr>
+            <a:r>
+              <a:rPr lang="en-US" sz="2200" b="1" dirty="0">
+                <a:solidFill>
+                  <a:srgbClr val="FFFFFF"/>
+                </a:solidFill>
+                <a:latin typeface="Calibri" pitchFamily="34" charset="0"/>
+                <a:ea typeface="Calibri" pitchFamily="34" charset="-122"/>
+                <a:cs typeface="Calibri" pitchFamily="34" charset="-120"/>
+              </a:rPr>
+              <a:t>✍️  10-Minute Write</a:t>
+            </a:r>
+            <a:endParaRPr lang="en-US" sz="2200" dirty="0"/>
+          </a:p>
+        </p:txBody>
       </p:sp>
       <p:sp>
         <p:nvSpPr>
@@ -2628,8 +2460,8 @@
         </p:nvSpPr>
         <p:spPr>
           <a:xfrm>
-            <a:off x="457200" y="1005840"/>
-            <a:ext cx="8046720" cy="292608"/>
+            <a:off x="365760" y="822960"/>
+            <a:ext cx="8229600" cy="237744"/>
           </a:xfrm>
           <a:prstGeom prst="rect">
             <a:avLst/>
@@ -2645,7 +2477,7 @@
               <a:buNone/>
             </a:pPr>
             <a:r>
-              <a:rPr lang="en-US" sz="1100" b="1" spc="200" kern="0" dirty="0">
+              <a:rPr lang="en-US" sz="1100" b="1" spc="100" kern="0" dirty="0">
                 <a:solidFill>
                   <a:srgbClr val="C7922C"/>
                 </a:solidFill>
@@ -2653,7 +2485,7 @@
                 <a:ea typeface="Calibri" pitchFamily="34" charset="-122"/>
                 <a:cs typeface="Calibri" pitchFamily="34" charset="-120"/>
               </a:rPr>
-              <a:t>📖 READ THE PROMPT — 1 MINUTE</a:t>
+              <a:t>READ THE PROMPT — 1 MINUTE</a:t>
             </a:r>
             <a:endParaRPr lang="en-US" sz="1100" dirty="0"/>
           </a:p>
@@ -2667,18 +2499,18 @@
         </p:nvSpPr>
         <p:spPr>
           <a:xfrm>
-            <a:off x="457200" y="1417320"/>
-            <a:ext cx="8229600" cy="1645920"/>
+            <a:off x="365760" y="1143000"/>
+            <a:ext cx="8412480" cy="1737360"/>
           </a:xfrm>
           <a:prstGeom prst="roundRect">
             <a:avLst>
-              <a:gd name="adj" fmla="val 5556"/>
+              <a:gd name="adj" fmla="val 5263"/>
             </a:avLst>
           </a:prstGeom>
           <a:solidFill>
             <a:srgbClr val="FEF6E8"/>
           </a:solidFill>
-          <a:ln w="12700">
+          <a:ln w="19050">
             <a:solidFill>
               <a:srgbClr val="C7922C"/>
             </a:solidFill>
@@ -2701,8 +2533,8 @@
         </p:nvSpPr>
         <p:spPr>
           <a:xfrm>
-            <a:off x="640080" y="1527048"/>
-            <a:ext cx="7863840" cy="1417320"/>
+            <a:off x="594360" y="1271016"/>
+            <a:ext cx="7955280" cy="1481328"/>
           </a:xfrm>
           <a:prstGeom prst="rect">
             <a:avLst/>
@@ -2718,7 +2550,7 @@
               <a:buNone/>
             </a:pPr>
             <a:r>
-              <a:rPr lang="en-US" sz="1800" i="1" dirty="0">
+              <a:rPr lang="en-US" sz="1700" dirty="0">
                 <a:solidFill>
                   <a:srgbClr val="1E293B"/>
                 </a:solidFill>
@@ -2726,9 +2558,9 @@
                 <a:ea typeface="Calibri" pitchFamily="34" charset="-122"/>
                 <a:cs typeface="Calibri" pitchFamily="34" charset="-120"/>
               </a:rPr>
-              <a:t>After reading both texts this week, has your idea of courage changed? Write what you thought courage meant at the beginning of the week, and what you think now.</a:t>
-            </a:r>
-            <a:endParaRPr lang="en-US" sz="1800" dirty="0"/>
+              <a:t>Write about a time you did the right thing when it was not the easy thing.</a:t>
+            </a:r>
+            <a:endParaRPr lang="en-US" sz="1700" dirty="0"/>
           </a:p>
         </p:txBody>
       </p:sp>
@@ -2740,8 +2572,8 @@
         </p:nvSpPr>
         <p:spPr>
           <a:xfrm>
-            <a:off x="640080" y="3246120"/>
-            <a:ext cx="7863840" cy="457200"/>
+            <a:off x="365760" y="3063240"/>
+            <a:ext cx="8412480" cy="365760"/>
           </a:xfrm>
           <a:prstGeom prst="rect">
             <a:avLst/>
@@ -2757,59 +2589,17 @@
               <a:buNone/>
             </a:pPr>
             <a:r>
-              <a:rPr lang="en-US" sz="1400" b="1" dirty="0">
-                <a:solidFill>
-                  <a:srgbClr val="0E1C42"/>
-                </a:solidFill>
-                <a:latin typeface="Calibri" pitchFamily="34" charset="0"/>
-                <a:ea typeface="Calibri" pitchFamily="34" charset="-122"/>
-                <a:cs typeface="Calibri" pitchFamily="34" charset="-120"/>
-              </a:rPr>
-              <a:t>Type in the chat </a:t>
-            </a:r>
-            <a:pPr indent="0" marL="0">
-              <a:buNone/>
-            </a:pPr>
-            <a:r>
-              <a:rPr lang="en-US" sz="1400" dirty="0">
-                <a:solidFill>
-                  <a:srgbClr val="1E293B"/>
-                </a:solidFill>
-                <a:latin typeface="Calibri" pitchFamily="34" charset="0"/>
-                <a:ea typeface="Calibri" pitchFamily="34" charset="-122"/>
-                <a:cs typeface="Calibri" pitchFamily="34" charset="-120"/>
-              </a:rPr>
-              <a:t>or </a:t>
-            </a:r>
-            <a:pPr indent="0" marL="0">
-              <a:buNone/>
-            </a:pPr>
-            <a:r>
-              <a:rPr lang="en-US" sz="1400" b="1" dirty="0">
-                <a:solidFill>
-                  <a:srgbClr val="0E1C42"/>
-                </a:solidFill>
-                <a:latin typeface="Calibri" pitchFamily="34" charset="0"/>
-                <a:ea typeface="Calibri" pitchFamily="34" charset="-122"/>
-                <a:cs typeface="Calibri" pitchFamily="34" charset="-120"/>
-              </a:rPr>
-              <a:t>write on paper</a:t>
-            </a:r>
-            <a:pPr indent="0" marL="0">
-              <a:buNone/>
-            </a:pPr>
-            <a:r>
-              <a:rPr lang="en-US" sz="1400" dirty="0">
-                <a:solidFill>
-                  <a:srgbClr val="1E293B"/>
-                </a:solidFill>
-                <a:latin typeface="Calibri" pitchFamily="34" charset="0"/>
-                <a:ea typeface="Calibri" pitchFamily="34" charset="-122"/>
-                <a:cs typeface="Calibri" pitchFamily="34" charset="-120"/>
-              </a:rPr>
-              <a:t> to hold up when we share.</a:t>
-            </a:r>
-            <a:endParaRPr lang="en-US" sz="1400" dirty="0"/>
+              <a:rPr lang="en-US" sz="1600" i="1" dirty="0">
+                <a:solidFill>
+                  <a:srgbClr val="64748B"/>
+                </a:solidFill>
+                <a:latin typeface="Calibri" pitchFamily="34" charset="0"/>
+                <a:ea typeface="Calibri" pitchFamily="34" charset="-122"/>
+                <a:cs typeface="Calibri" pitchFamily="34" charset="-120"/>
+              </a:rPr>
+              <a:t>Think first. You will have five minutes to write.</a:t>
+            </a:r>
+            <a:endParaRPr lang="en-US" sz="1600" dirty="0"/>
           </a:p>
         </p:txBody>
       </p:sp>
@@ -2847,14 +2637,34 @@
       </p:grpSpPr>
       <p:sp>
         <p:nvSpPr>
-          <p:cNvPr id="2" name="Text 0"/>
-          <p:cNvSpPr/>
-          <p:nvPr/>
-        </p:nvSpPr>
-        <p:spPr>
-          <a:xfrm>
-            <a:off x="457200" y="228600"/>
-            <a:ext cx="8229600" cy="640080"/>
+          <p:cNvPr id="2" name="Shape 0"/>
+          <p:cNvSpPr/>
+          <p:nvPr/>
+        </p:nvSpPr>
+        <p:spPr>
+          <a:xfrm>
+            <a:off x="0" y="0"/>
+            <a:ext cx="9144000" cy="566928"/>
+          </a:xfrm>
+          <a:prstGeom prst="rect">
+            <a:avLst/>
+          </a:prstGeom>
+          <a:solidFill>
+            <a:srgbClr val="C7922C"/>
+          </a:solidFill>
+          <a:ln/>
+        </p:spPr>
+      </p:sp>
+      <p:sp>
+        <p:nvSpPr>
+          <p:cNvPr id="3" name="Text 1"/>
+          <p:cNvSpPr/>
+          <p:nvPr/>
+        </p:nvSpPr>
+        <p:spPr>
+          <a:xfrm>
+            <a:off x="365760" y="54864"/>
+            <a:ext cx="8412480" cy="457200"/>
           </a:xfrm>
           <a:prstGeom prst="rect">
             <a:avLst/>
@@ -2866,11 +2676,50 @@
           <a:bodyPr wrap="square" lIns="0" tIns="0" rIns="0" bIns="0" rtlCol="0" anchor="ctr"/>
           <a:lstStyle/>
           <a:p>
-            <a:pPr algn="ctr" indent="0" marL="0">
-              <a:buNone/>
-            </a:pPr>
-            <a:r>
-              <a:rPr lang="en-US" sz="3200" b="1" dirty="0">
+            <a:pPr indent="0" marL="0">
+              <a:buNone/>
+            </a:pPr>
+            <a:r>
+              <a:rPr lang="en-US" sz="2200" b="1" dirty="0">
+                <a:solidFill>
+                  <a:srgbClr val="FFFFFF"/>
+                </a:solidFill>
+                <a:latin typeface="Calibri" pitchFamily="34" charset="0"/>
+                <a:ea typeface="Calibri" pitchFamily="34" charset="-122"/>
+                <a:cs typeface="Calibri" pitchFamily="34" charset="-120"/>
+              </a:rPr>
+              <a:t>✍️  Writing Time</a:t>
+            </a:r>
+            <a:endParaRPr lang="en-US" sz="2200" dirty="0"/>
+          </a:p>
+        </p:txBody>
+      </p:sp>
+      <p:sp>
+        <p:nvSpPr>
+          <p:cNvPr id="4" name="Text 2"/>
+          <p:cNvSpPr/>
+          <p:nvPr/>
+        </p:nvSpPr>
+        <p:spPr>
+          <a:xfrm>
+            <a:off x="365760" y="868680"/>
+            <a:ext cx="8412480" cy="502920"/>
+          </a:xfrm>
+          <a:prstGeom prst="rect">
+            <a:avLst/>
+          </a:prstGeom>
+          <a:noFill/>
+          <a:ln/>
+        </p:spPr>
+        <p:txBody>
+          <a:bodyPr wrap="square" lIns="0" tIns="0" rIns="0" bIns="0" rtlCol="0" anchor="ctr"/>
+          <a:lstStyle/>
+          <a:p>
+            <a:pPr indent="0" marL="0">
+              <a:buNone/>
+            </a:pPr>
+            <a:r>
+              <a:rPr lang="en-US" sz="2600" b="1" dirty="0">
                 <a:solidFill>
                   <a:srgbClr val="0E1C42"/>
                 </a:solidFill>
@@ -2878,22 +2727,22 @@
                 <a:ea typeface="Calibri" pitchFamily="34" charset="-122"/>
                 <a:cs typeface="Calibri" pitchFamily="34" charset="-120"/>
               </a:rPr>
-              <a:t>✏️  Writing Time</a:t>
-            </a:r>
-            <a:endParaRPr lang="en-US" sz="3200" dirty="0"/>
-          </a:p>
-        </p:txBody>
-      </p:sp>
-      <p:sp>
-        <p:nvSpPr>
-          <p:cNvPr id="3" name="Text 1"/>
-          <p:cNvSpPr/>
-          <p:nvPr/>
-        </p:nvSpPr>
-        <p:spPr>
-          <a:xfrm>
-            <a:off x="914400" y="822960"/>
-            <a:ext cx="7315200" cy="365760"/>
+              <a:t>5 minutes — keep your pencil moving!</a:t>
+            </a:r>
+            <a:endParaRPr lang="en-US" sz="2600" dirty="0"/>
+          </a:p>
+        </p:txBody>
+      </p:sp>
+      <p:sp>
+        <p:nvSpPr>
+          <p:cNvPr id="5" name="Text 3"/>
+          <p:cNvSpPr/>
+          <p:nvPr/>
+        </p:nvSpPr>
+        <p:spPr>
+          <a:xfrm>
+            <a:off x="365760" y="1463040"/>
+            <a:ext cx="8229600" cy="237744"/>
           </a:xfrm>
           <a:prstGeom prst="rect">
             <a:avLst/>
@@ -2905,11 +2754,11 @@
           <a:bodyPr wrap="square" lIns="0" tIns="0" rIns="0" bIns="0" rtlCol="0" anchor="ctr"/>
           <a:lstStyle/>
           <a:p>
-            <a:pPr algn="ctr" indent="0" marL="0">
-              <a:buNone/>
-            </a:pPr>
-            <a:r>
-              <a:rPr lang="en-US" sz="1600" dirty="0">
+            <a:pPr indent="0" marL="0">
+              <a:buNone/>
+            </a:pPr>
+            <a:r>
+              <a:rPr lang="en-US" sz="1100" b="1" spc="100" kern="0" dirty="0">
                 <a:solidFill>
                   <a:srgbClr val="C7922C"/>
                 </a:solidFill>
@@ -2917,32 +2766,32 @@
                 <a:ea typeface="Calibri" pitchFamily="34" charset="-122"/>
                 <a:cs typeface="Calibri" pitchFamily="34" charset="-120"/>
               </a:rPr>
-              <a:t>5 minutes — keep your pencil moving!</a:t>
-            </a:r>
-            <a:endParaRPr lang="en-US" sz="1600" dirty="0"/>
-          </a:p>
-        </p:txBody>
-      </p:sp>
-      <p:sp>
-        <p:nvSpPr>
-          <p:cNvPr id="4" name="Shape 2"/>
-          <p:cNvSpPr/>
-          <p:nvPr/>
-        </p:nvSpPr>
-        <p:spPr>
-          <a:xfrm>
-            <a:off x="457200" y="1371600"/>
-            <a:ext cx="8229600" cy="1280160"/>
+              <a:t>YOUR PROMPT</a:t>
+            </a:r>
+            <a:endParaRPr lang="en-US" sz="1100" dirty="0"/>
+          </a:p>
+        </p:txBody>
+      </p:sp>
+      <p:sp>
+        <p:nvSpPr>
+          <p:cNvPr id="6" name="Shape 4"/>
+          <p:cNvSpPr/>
+          <p:nvPr/>
+        </p:nvSpPr>
+        <p:spPr>
+          <a:xfrm>
+            <a:off x="365760" y="1737360"/>
+            <a:ext cx="8412480" cy="1417320"/>
           </a:xfrm>
           <a:prstGeom prst="roundRect">
             <a:avLst>
-              <a:gd name="adj" fmla="val 7143"/>
+              <a:gd name="adj" fmla="val 6452"/>
             </a:avLst>
           </a:prstGeom>
           <a:solidFill>
             <a:srgbClr val="FFFFFF"/>
           </a:solidFill>
-          <a:ln w="12700">
+          <a:ln w="19050">
             <a:solidFill>
               <a:srgbClr val="C7922C"/>
             </a:solidFill>
@@ -2959,44 +2808,30 @@
       </p:sp>
       <p:sp>
         <p:nvSpPr>
-          <p:cNvPr id="5" name="Text 3"/>
-          <p:cNvSpPr/>
-          <p:nvPr/>
-        </p:nvSpPr>
-        <p:spPr>
-          <a:xfrm>
-            <a:off x="640080" y="1417320"/>
-            <a:ext cx="7863840" cy="1188720"/>
-          </a:xfrm>
-          <a:prstGeom prst="rect">
-            <a:avLst/>
-          </a:prstGeom>
-          <a:noFill/>
-          <a:ln/>
-        </p:spPr>
-        <p:txBody>
-          <a:bodyPr wrap="square" lIns="0" tIns="0" rIns="0" bIns="0" rtlCol="0" anchor="t"/>
-          <a:lstStyle/>
-          <a:p>
-            <a:pPr indent="0" marL="0">
-              <a:buNone/>
-            </a:pPr>
-            <a:r>
-              <a:rPr lang="en-US" sz="1200" b="1" dirty="0">
-                <a:solidFill>
-                  <a:srgbClr val="C7922C"/>
-                </a:solidFill>
-                <a:latin typeface="Calibri" pitchFamily="34" charset="0"/>
-                <a:ea typeface="Calibri" pitchFamily="34" charset="-122"/>
-                <a:cs typeface="Calibri" pitchFamily="34" charset="-120"/>
-              </a:rPr>
-              <a:t>📖 Prompt: </a:t>
-            </a:r>
-            <a:pPr indent="0" marL="0">
-              <a:buNone/>
-            </a:pPr>
-            <a:r>
-              <a:rPr lang="en-US" sz="1200" i="1" dirty="0">
+          <p:cNvPr id="7" name="Text 5"/>
+          <p:cNvSpPr/>
+          <p:nvPr/>
+        </p:nvSpPr>
+        <p:spPr>
+          <a:xfrm>
+            <a:off x="594360" y="1865376"/>
+            <a:ext cx="7955280" cy="1161288"/>
+          </a:xfrm>
+          <a:prstGeom prst="rect">
+            <a:avLst/>
+          </a:prstGeom>
+          <a:noFill/>
+          <a:ln/>
+        </p:spPr>
+        <p:txBody>
+          <a:bodyPr wrap="square" lIns="0" tIns="0" rIns="0" bIns="0" rtlCol="0" anchor="ctr"/>
+          <a:lstStyle/>
+          <a:p>
+            <a:pPr indent="0" marL="0">
+              <a:buNone/>
+            </a:pPr>
+            <a:r>
+              <a:rPr lang="en-US" sz="1700" dirty="0">
                 <a:solidFill>
                   <a:srgbClr val="1E293B"/>
                 </a:solidFill>
@@ -3004,122 +2839,48 @@
                 <a:ea typeface="Calibri" pitchFamily="34" charset="-122"/>
                 <a:cs typeface="Calibri" pitchFamily="34" charset="-120"/>
               </a:rPr>
-              <a:t>After reading both texts this week, has your idea of courage changed? Write what you thought courage meant at the beginning of the week, and what you think now.</a:t>
-            </a:r>
-            <a:endParaRPr lang="en-US" sz="1200" dirty="0"/>
-          </a:p>
-        </p:txBody>
-      </p:sp>
-      <p:sp>
-        <p:nvSpPr>
-          <p:cNvPr id="6" name="Shape 4"/>
-          <p:cNvSpPr/>
-          <p:nvPr/>
-        </p:nvSpPr>
-        <p:spPr>
-          <a:xfrm>
-            <a:off x="2286000" y="2926080"/>
-            <a:ext cx="4572000" cy="1280160"/>
-          </a:xfrm>
-          <a:prstGeom prst="roundRect">
-            <a:avLst>
-              <a:gd name="adj" fmla="val 8571"/>
-            </a:avLst>
-          </a:prstGeom>
-          <a:solidFill>
-            <a:srgbClr val="FFFFFF"/>
-          </a:solidFill>
-          <a:ln/>
-          <a:effectLst>
-            <a:outerShdw sx="100000" sy="100000" kx="0" ky="0" algn="bl" rotWithShape="0" blurRad="101600" dist="38100" dir="2700000">
-              <a:srgbClr val="000000">
-                <a:alpha val="12000"/>
-              </a:srgbClr>
-            </a:outerShdw>
-          </a:effectLst>
-        </p:spPr>
-      </p:sp>
-      <p:sp>
-        <p:nvSpPr>
-          <p:cNvPr id="7" name="Text 5"/>
-          <p:cNvSpPr/>
-          <p:nvPr/>
-        </p:nvSpPr>
-        <p:spPr>
-          <a:xfrm>
-            <a:off x="2468880" y="3017520"/>
-            <a:ext cx="4206240" cy="1097280"/>
-          </a:xfrm>
-          <a:prstGeom prst="rect">
-            <a:avLst/>
-          </a:prstGeom>
-          <a:noFill/>
-          <a:ln/>
-        </p:spPr>
-        <p:txBody>
-          <a:bodyPr wrap="square" lIns="0" tIns="0" rIns="0" bIns="0" rtlCol="0" anchor="t"/>
-          <a:lstStyle/>
-          <a:p>
-            <a:pPr indent="0" marL="0">
-              <a:buNone/>
-            </a:pPr>
-            <a:r>
-              <a:rPr lang="en-US" sz="1400" b="1" dirty="0">
-                <a:solidFill>
-                  <a:srgbClr val="0E1C42"/>
-                </a:solidFill>
-                <a:latin typeface="Calibri" pitchFamily="34" charset="0"/>
-                <a:ea typeface="Calibri" pitchFamily="34" charset="-122"/>
-                <a:cs typeface="Calibri" pitchFamily="34" charset="-120"/>
-              </a:rPr>
-              <a:t>If you get stuck:
-</a:t>
-            </a:r>
-            <a:pPr indent="0" marL="0">
-              <a:buNone/>
-            </a:pPr>
-            <a:r>
-              <a:rPr lang="en-US" sz="1300" dirty="0">
-                <a:solidFill>
-                  <a:srgbClr val="1E293B"/>
-                </a:solidFill>
-                <a:latin typeface="Calibri" pitchFamily="34" charset="0"/>
-                <a:ea typeface="Calibri" pitchFamily="34" charset="-122"/>
-                <a:cs typeface="Calibri" pitchFamily="34" charset="-120"/>
-              </a:rPr>
-              <a:t>• Reread the prompt above
-</a:t>
-            </a:r>
-            <a:pPr indent="0" marL="0">
-              <a:buNone/>
-            </a:pPr>
-            <a:r>
-              <a:rPr lang="en-US" sz="1300" dirty="0">
-                <a:solidFill>
-                  <a:srgbClr val="1E293B"/>
-                </a:solidFill>
-                <a:latin typeface="Calibri" pitchFamily="34" charset="0"/>
-                <a:ea typeface="Calibri" pitchFamily="34" charset="-122"/>
-                <a:cs typeface="Calibri" pitchFamily="34" charset="-120"/>
-              </a:rPr>
-              <a:t>• Write "I'm thinking..." until a new idea comes
-</a:t>
-            </a:r>
-            <a:pPr indent="0" marL="0">
-              <a:buNone/>
-            </a:pPr>
-            <a:r>
-              <a:rPr lang="en-US" sz="1300" dirty="0">
-                <a:solidFill>
-                  <a:srgbClr val="1E293B"/>
-                </a:solidFill>
-                <a:latin typeface="Calibri" pitchFamily="34" charset="0"/>
-                <a:ea typeface="Calibri" pitchFamily="34" charset="-122"/>
-                <a:cs typeface="Calibri" pitchFamily="34" charset="-120"/>
-              </a:rPr>
-              <a:t>• Keep going — don't erase!</a:t>
-            </a:r>
-            <a:endParaRPr lang="en-US" sz="1400" dirty="0"/>
+              <a:t>Write about a time you did the right thing when it was not the easy thing.</a:t>
+            </a:r>
+            <a:endParaRPr lang="en-US" sz="1700" dirty="0"/>
+          </a:p>
+        </p:txBody>
+      </p:sp>
+      <p:sp>
+        <p:nvSpPr>
+          <p:cNvPr id="8" name="Text 6"/>
+          <p:cNvSpPr/>
+          <p:nvPr/>
+        </p:nvSpPr>
+        <p:spPr>
+          <a:xfrm>
+            <a:off x="365760" y="3291840"/>
+            <a:ext cx="8412480" cy="365760"/>
+          </a:xfrm>
+          <a:prstGeom prst="rect">
+            <a:avLst/>
+          </a:prstGeom>
+          <a:noFill/>
+          <a:ln/>
+        </p:spPr>
+        <p:txBody>
+          <a:bodyPr wrap="square" lIns="0" tIns="0" rIns="0" bIns="0" rtlCol="0" anchor="ctr"/>
+          <a:lstStyle/>
+          <a:p>
+            <a:pPr indent="0" marL="0">
+              <a:buNone/>
+            </a:pPr>
+            <a:r>
+              <a:rPr lang="en-US" sz="1500" i="1" dirty="0">
+                <a:solidFill>
+                  <a:srgbClr val="64748B"/>
+                </a:solidFill>
+                <a:latin typeface="Calibri" pitchFamily="34" charset="0"/>
+                <a:ea typeface="Calibri" pitchFamily="34" charset="-122"/>
+                <a:cs typeface="Calibri" pitchFamily="34" charset="-120"/>
+              </a:rPr>
+              <a:t>Do not stop to erase. If you get stuck, write the last word again and keep going.</a:t>
+            </a:r>
+            <a:endParaRPr lang="en-US" sz="1500" dirty="0"/>
           </a:p>
         </p:txBody>
       </p:sp>
@@ -3157,14 +2918,34 @@
       </p:grpSpPr>
       <p:sp>
         <p:nvSpPr>
-          <p:cNvPr id="2" name="Text 0"/>
-          <p:cNvSpPr/>
-          <p:nvPr/>
-        </p:nvSpPr>
-        <p:spPr>
-          <a:xfrm>
-            <a:off x="3657600" y="365760"/>
-            <a:ext cx="1828800" cy="640080"/>
+          <p:cNvPr id="2" name="Shape 0"/>
+          <p:cNvSpPr/>
+          <p:nvPr/>
+        </p:nvSpPr>
+        <p:spPr>
+          <a:xfrm>
+            <a:off x="0" y="0"/>
+            <a:ext cx="9144000" cy="566928"/>
+          </a:xfrm>
+          <a:prstGeom prst="rect">
+            <a:avLst/>
+          </a:prstGeom>
+          <a:solidFill>
+            <a:srgbClr val="34B76F"/>
+          </a:solidFill>
+          <a:ln/>
+        </p:spPr>
+      </p:sp>
+      <p:sp>
+        <p:nvSpPr>
+          <p:cNvPr id="3" name="Text 1"/>
+          <p:cNvSpPr/>
+          <p:nvPr/>
+        </p:nvSpPr>
+        <p:spPr>
+          <a:xfrm>
+            <a:off x="365760" y="54864"/>
+            <a:ext cx="8412480" cy="457200"/>
           </a:xfrm>
           <a:prstGeom prst="rect">
             <a:avLst/>
@@ -3176,31 +2957,34 @@
           <a:bodyPr wrap="square" lIns="0" tIns="0" rIns="0" bIns="0" rtlCol="0" anchor="ctr"/>
           <a:lstStyle/>
           <a:p>
-            <a:pPr algn="ctr" indent="0" marL="0">
-              <a:buNone/>
-            </a:pPr>
-            <a:r>
-              <a:rPr lang="en-US" sz="4000" dirty="0">
-                <a:solidFill>
-                  <a:srgbClr val="000000"/>
-                </a:solidFill>
-              </a:rPr>
-              <a:t>🔍</a:t>
-            </a:r>
-            <a:endParaRPr lang="en-US" sz="4000" dirty="0"/>
-          </a:p>
-        </p:txBody>
-      </p:sp>
-      <p:sp>
-        <p:nvSpPr>
-          <p:cNvPr id="3" name="Text 1"/>
-          <p:cNvSpPr/>
-          <p:nvPr/>
-        </p:nvSpPr>
-        <p:spPr>
-          <a:xfrm>
-            <a:off x="914400" y="914400"/>
-            <a:ext cx="7315200" cy="640080"/>
+            <a:pPr indent="0" marL="0">
+              <a:buNone/>
+            </a:pPr>
+            <a:r>
+              <a:rPr lang="en-US" sz="2200" b="1" dirty="0">
+                <a:solidFill>
+                  <a:srgbClr val="FFFFFF"/>
+                </a:solidFill>
+                <a:latin typeface="Calibri" pitchFamily="34" charset="0"/>
+                <a:ea typeface="Calibri" pitchFamily="34" charset="-122"/>
+                <a:cs typeface="Calibri" pitchFamily="34" charset="-120"/>
+              </a:rPr>
+              <a:t>🔍  Edit &amp; Revise</a:t>
+            </a:r>
+            <a:endParaRPr lang="en-US" sz="2200" dirty="0"/>
+          </a:p>
+        </p:txBody>
+      </p:sp>
+      <p:sp>
+        <p:nvSpPr>
+          <p:cNvPr id="4" name="Text 2"/>
+          <p:cNvSpPr/>
+          <p:nvPr/>
+        </p:nvSpPr>
+        <p:spPr>
+          <a:xfrm>
+            <a:off x="365760" y="868680"/>
+            <a:ext cx="8412480" cy="457200"/>
           </a:xfrm>
           <a:prstGeom prst="rect">
             <a:avLst/>
@@ -3212,11 +2996,11 @@
           <a:bodyPr wrap="square" lIns="0" tIns="0" rIns="0" bIns="0" rtlCol="0" anchor="ctr"/>
           <a:lstStyle/>
           <a:p>
-            <a:pPr algn="ctr" indent="0" marL="0">
-              <a:buNone/>
-            </a:pPr>
-            <a:r>
-              <a:rPr lang="en-US" sz="3200" b="1" dirty="0">
+            <a:pPr indent="0" marL="0">
+              <a:buNone/>
+            </a:pPr>
+            <a:r>
+              <a:rPr lang="en-US" sz="2400" b="1" dirty="0">
                 <a:solidFill>
                   <a:srgbClr val="0E1C42"/>
                 </a:solidFill>
@@ -3224,22 +3008,22 @@
                 <a:ea typeface="Calibri" pitchFamily="34" charset="-122"/>
                 <a:cs typeface="Calibri" pitchFamily="34" charset="-120"/>
               </a:rPr>
-              <a:t>Edit &amp; Revise</a:t>
-            </a:r>
-            <a:endParaRPr lang="en-US" sz="3200" dirty="0"/>
-          </a:p>
-        </p:txBody>
-      </p:sp>
-      <p:sp>
-        <p:nvSpPr>
-          <p:cNvPr id="4" name="Text 2"/>
-          <p:cNvSpPr/>
-          <p:nvPr/>
-        </p:nvSpPr>
-        <p:spPr>
-          <a:xfrm>
-            <a:off x="914400" y="1508760"/>
-            <a:ext cx="7315200" cy="457200"/>
+              <a:t>1 minute — pick ONE thing to fix.</a:t>
+            </a:r>
+            <a:endParaRPr lang="en-US" sz="2400" dirty="0"/>
+          </a:p>
+        </p:txBody>
+      </p:sp>
+      <p:sp>
+        <p:nvSpPr>
+          <p:cNvPr id="5" name="Text 3"/>
+          <p:cNvSpPr/>
+          <p:nvPr/>
+        </p:nvSpPr>
+        <p:spPr>
+          <a:xfrm>
+            <a:off x="365760" y="1417320"/>
+            <a:ext cx="8229600" cy="237744"/>
           </a:xfrm>
           <a:prstGeom prst="rect">
             <a:avLst/>
@@ -3251,11 +3035,11 @@
           <a:bodyPr wrap="square" lIns="0" tIns="0" rIns="0" bIns="0" rtlCol="0" anchor="ctr"/>
           <a:lstStyle/>
           <a:p>
-            <a:pPr algn="ctr" indent="0" marL="0">
-              <a:buNone/>
-            </a:pPr>
-            <a:r>
-              <a:rPr lang="en-US" sz="1600" dirty="0">
+            <a:pPr indent="0" marL="0">
+              <a:buNone/>
+            </a:pPr>
+            <a:r>
+              <a:rPr lang="en-US" sz="1100" b="1" spc="100" kern="0" dirty="0">
                 <a:solidFill>
                   <a:srgbClr val="34B76F"/>
                 </a:solidFill>
@@ -3263,26 +3047,26 @@
                 <a:ea typeface="Calibri" pitchFamily="34" charset="-122"/>
                 <a:cs typeface="Calibri" pitchFamily="34" charset="-120"/>
               </a:rPr>
-              <a:t>1 minute — pick ONE thing to fix</a:t>
-            </a:r>
-            <a:endParaRPr lang="en-US" sz="1600" dirty="0"/>
-          </a:p>
-        </p:txBody>
-      </p:sp>
-      <p:sp>
-        <p:nvSpPr>
-          <p:cNvPr id="5" name="Shape 3"/>
-          <p:cNvSpPr/>
-          <p:nvPr/>
-        </p:nvSpPr>
-        <p:spPr>
-          <a:xfrm>
-            <a:off x="1371600" y="2103120"/>
-            <a:ext cx="6400800" cy="640080"/>
+              <a:t>TODAY'S EDIT FOCUS</a:t>
+            </a:r>
+            <a:endParaRPr lang="en-US" sz="1100" dirty="0"/>
+          </a:p>
+        </p:txBody>
+      </p:sp>
+      <p:sp>
+        <p:nvSpPr>
+          <p:cNvPr id="6" name="Shape 4"/>
+          <p:cNvSpPr/>
+          <p:nvPr/>
+        </p:nvSpPr>
+        <p:spPr>
+          <a:xfrm>
+            <a:off x="365760" y="1691640"/>
+            <a:ext cx="8412480" cy="777240"/>
           </a:xfrm>
           <a:prstGeom prst="roundRect">
             <a:avLst>
-              <a:gd name="adj" fmla="val 14286"/>
+              <a:gd name="adj" fmla="val 11765"/>
             </a:avLst>
           </a:prstGeom>
           <a:solidFill>
@@ -3305,14 +3089,14 @@
       </p:sp>
       <p:sp>
         <p:nvSpPr>
-          <p:cNvPr id="6" name="Text 4"/>
-          <p:cNvSpPr/>
-          <p:nvPr/>
-        </p:nvSpPr>
-        <p:spPr>
-          <a:xfrm>
-            <a:off x="1554480" y="2148840"/>
-            <a:ext cx="6035040" cy="548640"/>
+          <p:cNvPr id="7" name="Text 5"/>
+          <p:cNvSpPr/>
+          <p:nvPr/>
+        </p:nvSpPr>
+        <p:spPr>
+          <a:xfrm>
+            <a:off x="594360" y="1819656"/>
+            <a:ext cx="7955280" cy="521208"/>
           </a:xfrm>
           <a:prstGeom prst="rect">
             <a:avLst/>
@@ -3328,21 +3112,7 @@
               <a:buNone/>
             </a:pPr>
             <a:r>
-              <a:rPr lang="en-US" sz="1400" b="1" dirty="0">
-                <a:solidFill>
-                  <a:srgbClr val="34B76F"/>
-                </a:solidFill>
-                <a:latin typeface="Calibri" pitchFamily="34" charset="0"/>
-                <a:ea typeface="Calibri" pitchFamily="34" charset="-122"/>
-                <a:cs typeface="Calibri" pitchFamily="34" charset="-120"/>
-              </a:rPr>
-              <a:t>Today's check: </a:t>
-            </a:r>
-            <a:pPr indent="0" marL="0">
-              <a:buNone/>
-            </a:pPr>
-            <a:r>
-              <a:rPr lang="en-US" sz="1400" dirty="0">
+              <a:rPr lang="en-US" sz="1700" dirty="0">
                 <a:solidFill>
                   <a:srgbClr val="1E293B"/>
                 </a:solidFill>
@@ -3350,40 +3120,11 @@
                 <a:ea typeface="Calibri" pitchFamily="34" charset="-122"/>
                 <a:cs typeface="Calibri" pitchFamily="34" charset="-120"/>
               </a:rPr>
-              <a:t>Did I explain both my old thinking and my new thinking?</a:t>
-            </a:r>
-            <a:endParaRPr lang="en-US" sz="1400" dirty="0"/>
-          </a:p>
-        </p:txBody>
-      </p:sp>
-      <p:sp>
-        <p:nvSpPr>
-          <p:cNvPr id="7" name="Shape 5"/>
-          <p:cNvSpPr/>
-          <p:nvPr/>
-        </p:nvSpPr>
-        <p:spPr>
-          <a:xfrm>
-            <a:off x="1371600" y="2926080"/>
-            <a:ext cx="6400800" cy="1463040"/>
-          </a:xfrm>
-          <a:prstGeom prst="roundRect">
-            <a:avLst>
-              <a:gd name="adj" fmla="val 6250"/>
-            </a:avLst>
-          </a:prstGeom>
-          <a:solidFill>
-            <a:srgbClr val="FFFFFF"/>
-          </a:solidFill>
-          <a:ln/>
-          <a:effectLst>
-            <a:outerShdw sx="100000" sy="100000" kx="0" ky="0" algn="bl" rotWithShape="0" blurRad="101600" dist="38100" dir="2700000">
-              <a:srgbClr val="000000">
-                <a:alpha val="12000"/>
-              </a:srgbClr>
-            </a:outerShdw>
-          </a:effectLst>
-        </p:spPr>
+              <a:t>Did I read my writing out loud to check that it makes sense?</a:t>
+            </a:r>
+            <a:endParaRPr lang="en-US" sz="1700" dirty="0"/>
+          </a:p>
+        </p:txBody>
       </p:sp>
       <p:sp>
         <p:nvSpPr>
@@ -3393,45 +3134,24 @@
         </p:nvSpPr>
         <p:spPr>
           <a:xfrm>
-            <a:off x="1554480" y="3017520"/>
-            <a:ext cx="6035040" cy="1280160"/>
-          </a:xfrm>
-          <a:prstGeom prst="rect">
-            <a:avLst/>
-          </a:prstGeom>
-          <a:noFill/>
-          <a:ln/>
-        </p:spPr>
-        <p:txBody>
-          <a:bodyPr wrap="square" lIns="0" tIns="0" rIns="0" bIns="0" rtlCol="0" anchor="t"/>
-          <a:lstStyle/>
-          <a:p>
-            <a:pPr indent="0" marL="0">
-              <a:spcAft>
-                <a:spcPts val="200"/>
-              </a:spcAft>
-              <a:buNone/>
-            </a:pPr>
-            <a:r>
-              <a:rPr lang="en-US" sz="1300" b="1" dirty="0">
-                <a:solidFill>
-                  <a:srgbClr val="0E1C42"/>
-                </a:solidFill>
-                <a:latin typeface="Calibri" pitchFamily="34" charset="0"/>
-                <a:ea typeface="Calibri" pitchFamily="34" charset="-122"/>
-                <a:cs typeface="Calibri" pitchFamily="34" charset="-120"/>
-              </a:rPr>
-              <a:t>Quick check:
-</a:t>
-            </a:r>
-            <a:pPr indent="0" marL="0">
-              <a:spcAft>
-                <a:spcPts val="200"/>
-              </a:spcAft>
-              <a:buNone/>
-            </a:pPr>
-            <a:r>
-              <a:rPr lang="en-US" sz="1200" dirty="0">
+            <a:off x="365760" y="2651760"/>
+            <a:ext cx="8412480" cy="365760"/>
+          </a:xfrm>
+          <a:prstGeom prst="rect">
+            <a:avLst/>
+          </a:prstGeom>
+          <a:noFill/>
+          <a:ln/>
+        </p:spPr>
+        <p:txBody>
+          <a:bodyPr wrap="square" lIns="0" tIns="0" rIns="0" bIns="0" rtlCol="0" anchor="ctr"/>
+          <a:lstStyle/>
+          <a:p>
+            <a:pPr indent="0" marL="0">
+              <a:buNone/>
+            </a:pPr>
+            <a:r>
+              <a:rPr lang="en-US" sz="1500" b="1" dirty="0">
                 <a:solidFill>
                   <a:srgbClr val="1E293B"/>
                 </a:solidFill>
@@ -3439,17 +3159,13 @@
                 <a:ea typeface="Calibri" pitchFamily="34" charset="-122"/>
                 <a:cs typeface="Calibri" pitchFamily="34" charset="-120"/>
               </a:rPr>
-              <a:t>□ Capital letters at the start of every sentence
-</a:t>
-            </a:r>
-            <a:pPr indent="0" marL="0">
-              <a:spcAft>
-                <a:spcPts val="200"/>
-              </a:spcAft>
-              <a:buNone/>
-            </a:pPr>
-            <a:r>
-              <a:rPr lang="en-US" sz="1200" dirty="0">
+              <a:t>Quick check:  </a:t>
+            </a:r>
+            <a:pPr indent="0" marL="0">
+              <a:buNone/>
+            </a:pPr>
+            <a:r>
+              <a:rPr lang="en-US" sz="1500" dirty="0">
                 <a:solidFill>
                   <a:srgbClr val="1E293B"/>
                 </a:solidFill>
@@ -3457,45 +3173,9 @@
                 <a:ea typeface="Calibri" pitchFamily="34" charset="-122"/>
                 <a:cs typeface="Calibri" pitchFamily="34" charset="-120"/>
               </a:rPr>
-              <a:t>□ End punctuation ( .  ?  ! )
-</a:t>
-            </a:r>
-            <a:pPr indent="0" marL="0">
-              <a:spcAft>
-                <a:spcPts val="200"/>
-              </a:spcAft>
-              <a:buNone/>
-            </a:pPr>
-            <a:r>
-              <a:rPr lang="en-US" sz="1200" dirty="0">
-                <a:solidFill>
-                  <a:srgbClr val="1E293B"/>
-                </a:solidFill>
-                <a:latin typeface="Calibri" pitchFamily="34" charset="0"/>
-                <a:ea typeface="Calibri" pitchFamily="34" charset="-122"/>
-                <a:cs typeface="Calibri" pitchFamily="34" charset="-120"/>
-              </a:rPr>
-              <a:t>□ Spelling — circle any words that look wrong
-</a:t>
-            </a:r>
-            <a:pPr indent="0" marL="0">
-              <a:spcAft>
-                <a:spcPts val="200"/>
-              </a:spcAft>
-              <a:buNone/>
-            </a:pPr>
-            <a:r>
-              <a:rPr lang="en-US" sz="1200" dirty="0">
-                <a:solidFill>
-                  <a:srgbClr val="1E293B"/>
-                </a:solidFill>
-                <a:latin typeface="Calibri" pitchFamily="34" charset="0"/>
-                <a:ea typeface="Calibri" pitchFamily="34" charset="-122"/>
-                <a:cs typeface="Calibri" pitchFamily="34" charset="-120"/>
-              </a:rPr>
-              <a:t>□ Read it quietly to yourself — does it sound right?</a:t>
-            </a:r>
-            <a:endParaRPr lang="en-US" sz="1300" dirty="0"/>
+              <a:t>capitals  ·  end punctuation  ·  circle a word you are unsure of  ·  read it aloud</a:t>
+            </a:r>
+            <a:endParaRPr lang="en-US" sz="1500" dirty="0"/>
           </a:p>
         </p:txBody>
       </p:sp>
@@ -3533,14 +3213,34 @@
       </p:grpSpPr>
       <p:sp>
         <p:nvSpPr>
-          <p:cNvPr id="2" name="Text 0"/>
-          <p:cNvSpPr/>
-          <p:nvPr/>
-        </p:nvSpPr>
-        <p:spPr>
-          <a:xfrm>
-            <a:off x="3657600" y="457200"/>
-            <a:ext cx="1828800" cy="731520"/>
+          <p:cNvPr id="2" name="Shape 0"/>
+          <p:cNvSpPr/>
+          <p:nvPr/>
+        </p:nvSpPr>
+        <p:spPr>
+          <a:xfrm>
+            <a:off x="0" y="0"/>
+            <a:ext cx="9144000" cy="566928"/>
+          </a:xfrm>
+          <a:prstGeom prst="rect">
+            <a:avLst/>
+          </a:prstGeom>
+          <a:solidFill>
+            <a:srgbClr val="55C8E8"/>
+          </a:solidFill>
+          <a:ln/>
+        </p:spPr>
+      </p:sp>
+      <p:sp>
+        <p:nvSpPr>
+          <p:cNvPr id="3" name="Text 1"/>
+          <p:cNvSpPr/>
+          <p:nvPr/>
+        </p:nvSpPr>
+        <p:spPr>
+          <a:xfrm>
+            <a:off x="365760" y="54864"/>
+            <a:ext cx="8412480" cy="457200"/>
           </a:xfrm>
           <a:prstGeom prst="rect">
             <a:avLst/>
@@ -3552,31 +3252,34 @@
           <a:bodyPr wrap="square" lIns="0" tIns="0" rIns="0" bIns="0" rtlCol="0" anchor="ctr"/>
           <a:lstStyle/>
           <a:p>
-            <a:pPr algn="ctr" indent="0" marL="0">
-              <a:buNone/>
-            </a:pPr>
-            <a:r>
-              <a:rPr lang="en-US" sz="4400" dirty="0">
-                <a:solidFill>
-                  <a:srgbClr val="000000"/>
-                </a:solidFill>
-              </a:rPr>
-              <a:t>🗣️</a:t>
-            </a:r>
-            <a:endParaRPr lang="en-US" sz="4400" dirty="0"/>
-          </a:p>
-        </p:txBody>
-      </p:sp>
-      <p:sp>
-        <p:nvSpPr>
-          <p:cNvPr id="3" name="Text 1"/>
-          <p:cNvSpPr/>
-          <p:nvPr/>
-        </p:nvSpPr>
-        <p:spPr>
-          <a:xfrm>
-            <a:off x="914400" y="1097280"/>
-            <a:ext cx="7315200" cy="640080"/>
+            <a:pPr indent="0" marL="0">
+              <a:buNone/>
+            </a:pPr>
+            <a:r>
+              <a:rPr lang="en-US" sz="2200" b="1" dirty="0">
+                <a:solidFill>
+                  <a:srgbClr val="FFFFFF"/>
+                </a:solidFill>
+                <a:latin typeface="Calibri" pitchFamily="34" charset="0"/>
+                <a:ea typeface="Calibri" pitchFamily="34" charset="-122"/>
+                <a:cs typeface="Calibri" pitchFamily="34" charset="-120"/>
+              </a:rPr>
+              <a:t>🗣️  Share Time</a:t>
+            </a:r>
+            <a:endParaRPr lang="en-US" sz="2200" dirty="0"/>
+          </a:p>
+        </p:txBody>
+      </p:sp>
+      <p:sp>
+        <p:nvSpPr>
+          <p:cNvPr id="4" name="Text 2"/>
+          <p:cNvSpPr/>
+          <p:nvPr/>
+        </p:nvSpPr>
+        <p:spPr>
+          <a:xfrm>
+            <a:off x="365760" y="1005840"/>
+            <a:ext cx="8412480" cy="548640"/>
           </a:xfrm>
           <a:prstGeom prst="rect">
             <a:avLst/>
@@ -3588,11 +3291,11 @@
           <a:bodyPr wrap="square" lIns="0" tIns="0" rIns="0" bIns="0" rtlCol="0" anchor="ctr"/>
           <a:lstStyle/>
           <a:p>
-            <a:pPr algn="ctr" indent="0" marL="0">
-              <a:buNone/>
-            </a:pPr>
-            <a:r>
-              <a:rPr lang="en-US" sz="3400" b="1" dirty="0">
+            <a:pPr indent="0" marL="0">
+              <a:buNone/>
+            </a:pPr>
+            <a:r>
+              <a:rPr lang="en-US" sz="2600" b="1" dirty="0">
                 <a:solidFill>
                   <a:srgbClr val="0E1C42"/>
                 </a:solidFill>
@@ -3600,22 +3303,22 @@
                 <a:ea typeface="Calibri" pitchFamily="34" charset="-122"/>
                 <a:cs typeface="Calibri" pitchFamily="34" charset="-120"/>
               </a:rPr>
-              <a:t>Share Time</a:t>
-            </a:r>
-            <a:endParaRPr lang="en-US" sz="3400" dirty="0"/>
-          </a:p>
-        </p:txBody>
-      </p:sp>
-      <p:sp>
-        <p:nvSpPr>
-          <p:cNvPr id="4" name="Text 2"/>
-          <p:cNvSpPr/>
-          <p:nvPr/>
-        </p:nvSpPr>
-        <p:spPr>
-          <a:xfrm>
-            <a:off x="914400" y="1737360"/>
-            <a:ext cx="7315200" cy="457200"/>
+              <a:t>3 minutes — let's hear your writing!</a:t>
+            </a:r>
+            <a:endParaRPr lang="en-US" sz="2600" dirty="0"/>
+          </a:p>
+        </p:txBody>
+      </p:sp>
+      <p:sp>
+        <p:nvSpPr>
+          <p:cNvPr id="5" name="Text 3"/>
+          <p:cNvSpPr/>
+          <p:nvPr/>
+        </p:nvSpPr>
+        <p:spPr>
+          <a:xfrm>
+            <a:off x="365760" y="1691640"/>
+            <a:ext cx="8412480" cy="457200"/>
           </a:xfrm>
           <a:prstGeom prst="rect">
             <a:avLst/>
@@ -3627,164 +3330,21 @@
           <a:bodyPr wrap="square" lIns="0" tIns="0" rIns="0" bIns="0" rtlCol="0" anchor="ctr"/>
           <a:lstStyle/>
           <a:p>
-            <a:pPr algn="ctr" indent="0" marL="0">
+            <a:pPr indent="0" marL="0">
               <a:buNone/>
             </a:pPr>
             <a:r>
               <a:rPr lang="en-US" sz="1700" dirty="0">
                 <a:solidFill>
-                  <a:srgbClr val="55C8E8"/>
-                </a:solidFill>
-                <a:latin typeface="Calibri" pitchFamily="34" charset="0"/>
-                <a:ea typeface="Calibri" pitchFamily="34" charset="-122"/>
-                <a:cs typeface="Calibri" pitchFamily="34" charset="-120"/>
-              </a:rPr>
-              <a:t>3 minutes — let's hear your writing!</a:t>
+                  <a:srgbClr val="1E293B"/>
+                </a:solidFill>
+                <a:latin typeface="Calibri" pitchFamily="34" charset="0"/>
+                <a:ea typeface="Calibri" pitchFamily="34" charset="-122"/>
+                <a:cs typeface="Calibri" pitchFamily="34" charset="-120"/>
+              </a:rPr>
+              <a:t>Raise your hand  ·  paste it in the chat  ·  or hold your paper up to the camera</a:t>
             </a:r>
             <a:endParaRPr lang="en-US" sz="1700" dirty="0"/>
-          </a:p>
-        </p:txBody>
-      </p:sp>
-      <p:sp>
-        <p:nvSpPr>
-          <p:cNvPr id="5" name="Shape 3"/>
-          <p:cNvSpPr/>
-          <p:nvPr/>
-        </p:nvSpPr>
-        <p:spPr>
-          <a:xfrm>
-            <a:off x="1828800" y="2468880"/>
-            <a:ext cx="5486400" cy="1645920"/>
-          </a:xfrm>
-          <a:prstGeom prst="roundRect">
-            <a:avLst>
-              <a:gd name="adj" fmla="val 6667"/>
-            </a:avLst>
-          </a:prstGeom>
-          <a:solidFill>
-            <a:srgbClr val="FFFFFF"/>
-          </a:solidFill>
-          <a:ln/>
-          <a:effectLst>
-            <a:outerShdw sx="100000" sy="100000" kx="0" ky="0" algn="bl" rotWithShape="0" blurRad="101600" dist="38100" dir="2700000">
-              <a:srgbClr val="000000">
-                <a:alpha val="12000"/>
-              </a:srgbClr>
-            </a:outerShdw>
-          </a:effectLst>
-        </p:spPr>
-      </p:sp>
-      <p:sp>
-        <p:nvSpPr>
-          <p:cNvPr id="6" name="Text 4"/>
-          <p:cNvSpPr/>
-          <p:nvPr/>
-        </p:nvSpPr>
-        <p:spPr>
-          <a:xfrm>
-            <a:off x="2103120" y="2560320"/>
-            <a:ext cx="4937760" cy="1463040"/>
-          </a:xfrm>
-          <a:prstGeom prst="rect">
-            <a:avLst/>
-          </a:prstGeom>
-          <a:noFill/>
-          <a:ln/>
-        </p:spPr>
-        <p:txBody>
-          <a:bodyPr wrap="square" lIns="0" tIns="0" rIns="0" bIns="0" rtlCol="0" anchor="t"/>
-          <a:lstStyle/>
-          <a:p>
-            <a:pPr indent="0" marL="0">
-              <a:spcAft>
-                <a:spcPts val="200"/>
-              </a:spcAft>
-              <a:buNone/>
-            </a:pPr>
-            <a:r>
-              <a:rPr lang="en-US" sz="1400" b="1" dirty="0">
-                <a:solidFill>
-                  <a:srgbClr val="0E1C42"/>
-                </a:solidFill>
-                <a:latin typeface="Calibri" pitchFamily="34" charset="0"/>
-                <a:ea typeface="Calibri" pitchFamily="34" charset="-122"/>
-                <a:cs typeface="Calibri" pitchFamily="34" charset="-120"/>
-              </a:rPr>
-              <a:t>How to share:
-</a:t>
-            </a:r>
-            <a:pPr indent="0" marL="0">
-              <a:spcAft>
-                <a:spcPts val="200"/>
-              </a:spcAft>
-              <a:buNone/>
-            </a:pPr>
-            <a:r>
-              <a:rPr lang="en-US" sz="1300" dirty="0">
-                <a:solidFill>
-                  <a:srgbClr val="1E293B"/>
-                </a:solidFill>
-                <a:latin typeface="Calibri" pitchFamily="34" charset="0"/>
-                <a:ea typeface="Calibri" pitchFamily="34" charset="-122"/>
-                <a:cs typeface="Calibri" pitchFamily="34" charset="-120"/>
-              </a:rPr>
-              <a:t>✋ Raise your hand if you want to read yours aloud
-</a:t>
-            </a:r>
-            <a:pPr indent="0" marL="0">
-              <a:spcAft>
-                <a:spcPts val="200"/>
-              </a:spcAft>
-              <a:buNone/>
-            </a:pPr>
-            <a:r>
-              <a:rPr lang="en-US" sz="1300" dirty="0">
-                <a:solidFill>
-                  <a:srgbClr val="1E293B"/>
-                </a:solidFill>
-                <a:latin typeface="Calibri" pitchFamily="34" charset="0"/>
-                <a:ea typeface="Calibri" pitchFamily="34" charset="-122"/>
-                <a:cs typeface="Calibri" pitchFamily="34" charset="-120"/>
-              </a:rPr>
-              <a:t>💬 Or paste your writing in the chat
-</a:t>
-            </a:r>
-            <a:pPr indent="0" marL="0">
-              <a:spcAft>
-                <a:spcPts val="200"/>
-              </a:spcAft>
-              <a:buNone/>
-            </a:pPr>
-            <a:r>
-              <a:rPr lang="en-US" sz="1300" dirty="0">
-                <a:solidFill>
-                  <a:srgbClr val="1E293B"/>
-                </a:solidFill>
-                <a:latin typeface="Calibri" pitchFamily="34" charset="0"/>
-                <a:ea typeface="Calibri" pitchFamily="34" charset="-122"/>
-                <a:cs typeface="Calibri" pitchFamily="34" charset="-120"/>
-              </a:rPr>
-              <a:t>👂 Listen respectfully when others share
-</a:t>
-            </a:r>
-            <a:pPr indent="0" marL="0">
-              <a:spcAft>
-                <a:spcPts val="200"/>
-              </a:spcAft>
-              <a:buNone/>
-            </a:pPr>
-            <a:r>
-              <a:rPr lang="en-US" sz="1200" i="1" dirty="0">
-                <a:solidFill>
-                  <a:srgbClr val="64748B"/>
-                </a:solidFill>
-                <a:latin typeface="Calibri" pitchFamily="34" charset="0"/>
-                <a:ea typeface="Calibri" pitchFamily="34" charset="-122"/>
-                <a:cs typeface="Calibri" pitchFamily="34" charset="-120"/>
-              </a:rPr>
-              <a:t>Every writer's ideas matter — there are no wrong answers.</a:t>
-            </a:r>
-            <a:endParaRPr lang="en-US" sz="1400" dirty="0"/>
           </a:p>
         </p:txBody>
       </p:sp>
@@ -3802,7 +3362,7 @@
     <p:bg>
       <p:bgPr>
         <a:solidFill>
-          <a:srgbClr val="E5F7FC"/>
+          <a:srgbClr val="F8FAFC"/>
         </a:solidFill>
       </p:bgPr>
     </p:bg>
@@ -3822,14 +3382,34 @@
       </p:grpSpPr>
       <p:sp>
         <p:nvSpPr>
-          <p:cNvPr id="2" name="Text 0"/>
-          <p:cNvSpPr/>
-          <p:nvPr/>
-        </p:nvSpPr>
-        <p:spPr>
-          <a:xfrm>
-            <a:off x="365760" y="164592"/>
-            <a:ext cx="5943600" cy="566928"/>
+          <p:cNvPr id="2" name="Shape 0"/>
+          <p:cNvSpPr/>
+          <p:nvPr/>
+        </p:nvSpPr>
+        <p:spPr>
+          <a:xfrm>
+            <a:off x="0" y="0"/>
+            <a:ext cx="9144000" cy="566928"/>
+          </a:xfrm>
+          <a:prstGeom prst="rect">
+            <a:avLst/>
+          </a:prstGeom>
+          <a:solidFill>
+            <a:srgbClr val="34B76F"/>
+          </a:solidFill>
+          <a:ln/>
+        </p:spPr>
+      </p:sp>
+      <p:sp>
+        <p:nvSpPr>
+          <p:cNvPr id="3" name="Text 1"/>
+          <p:cNvSpPr/>
+          <p:nvPr/>
+        </p:nvSpPr>
+        <p:spPr>
+          <a:xfrm>
+            <a:off x="365760" y="54864"/>
+            <a:ext cx="8412480" cy="457200"/>
           </a:xfrm>
           <a:prstGeom prst="rect">
             <a:avLst/>
@@ -3841,11 +3421,89 @@
           <a:bodyPr wrap="square" lIns="0" tIns="0" rIns="0" bIns="0" rtlCol="0" anchor="ctr"/>
           <a:lstStyle/>
           <a:p>
-            <a:pPr algn="l" indent="0" marL="0">
-              <a:buNone/>
-            </a:pPr>
-            <a:r>
-              <a:rPr lang="en-US" sz="2800" b="1" dirty="0">
+            <a:pPr indent="0" marL="0">
+              <a:buNone/>
+            </a:pPr>
+            <a:r>
+              <a:rPr lang="en-US" sz="2200" b="1" dirty="0">
+                <a:solidFill>
+                  <a:srgbClr val="FFFFFF"/>
+                </a:solidFill>
+                <a:latin typeface="Calibri" pitchFamily="34" charset="0"/>
+                <a:ea typeface="Calibri" pitchFamily="34" charset="-122"/>
+                <a:cs typeface="Calibri" pitchFamily="34" charset="-120"/>
+              </a:rPr>
+              <a:t>📖  Today</a:t>
+            </a:r>
+            <a:endParaRPr lang="en-US" sz="2200" dirty="0"/>
+          </a:p>
+        </p:txBody>
+      </p:sp>
+      <p:sp>
+        <p:nvSpPr>
+          <p:cNvPr id="4" name="Text 2"/>
+          <p:cNvSpPr/>
+          <p:nvPr/>
+        </p:nvSpPr>
+        <p:spPr>
+          <a:xfrm>
+            <a:off x="365760" y="777240"/>
+            <a:ext cx="8229600" cy="237744"/>
+          </a:xfrm>
+          <a:prstGeom prst="rect">
+            <a:avLst/>
+          </a:prstGeom>
+          <a:noFill/>
+          <a:ln/>
+        </p:spPr>
+        <p:txBody>
+          <a:bodyPr wrap="square" lIns="0" tIns="0" rIns="0" bIns="0" rtlCol="0" anchor="ctr"/>
+          <a:lstStyle/>
+          <a:p>
+            <a:pPr indent="0" marL="0">
+              <a:buNone/>
+            </a:pPr>
+            <a:r>
+              <a:rPr lang="en-US" sz="1100" b="1" spc="100" kern="0" dirty="0">
+                <a:solidFill>
+                  <a:srgbClr val="8B6FC0"/>
+                </a:solidFill>
+                <a:latin typeface="Calibri" pitchFamily="34" charset="0"/>
+                <a:ea typeface="Calibri" pitchFamily="34" charset="-122"/>
+                <a:cs typeface="Calibri" pitchFamily="34" charset="-120"/>
+              </a:rPr>
+              <a:t>READING</a:t>
+            </a:r>
+            <a:endParaRPr lang="en-US" sz="1100" dirty="0"/>
+          </a:p>
+        </p:txBody>
+      </p:sp>
+      <p:sp>
+        <p:nvSpPr>
+          <p:cNvPr id="5" name="Text 3"/>
+          <p:cNvSpPr/>
+          <p:nvPr/>
+        </p:nvSpPr>
+        <p:spPr>
+          <a:xfrm>
+            <a:off x="365760" y="1014984"/>
+            <a:ext cx="8412480" cy="365760"/>
+          </a:xfrm>
+          <a:prstGeom prst="rect">
+            <a:avLst/>
+          </a:prstGeom>
+          <a:noFill/>
+          <a:ln/>
+        </p:spPr>
+        <p:txBody>
+          <a:bodyPr wrap="square" lIns="0" tIns="0" rIns="0" bIns="0" rtlCol="0" anchor="ctr"/>
+          <a:lstStyle/>
+          <a:p>
+            <a:pPr indent="0" marL="0">
+              <a:buNone/>
+            </a:pPr>
+            <a:r>
+              <a:rPr lang="en-US" sz="2000" b="1" dirty="0">
                 <a:solidFill>
                   <a:srgbClr val="0E1C42"/>
                 </a:solidFill>
@@ -3853,155 +3511,71 @@
                 <a:ea typeface="Calibri" pitchFamily="34" charset="-122"/>
                 <a:cs typeface="Calibri" pitchFamily="34" charset="-120"/>
               </a:rPr>
-              <a:t>💡 Today's Focus</a:t>
-            </a:r>
-            <a:endParaRPr lang="en-US" sz="2800" dirty="0"/>
-          </a:p>
-        </p:txBody>
-      </p:sp>
-      <p:sp>
-        <p:nvSpPr>
-          <p:cNvPr id="3" name="Shape 1"/>
-          <p:cNvSpPr/>
-          <p:nvPr/>
-        </p:nvSpPr>
-        <p:spPr>
-          <a:xfrm>
-            <a:off x="365760" y="749808"/>
-            <a:ext cx="8412480" cy="0"/>
-          </a:xfrm>
-          <a:prstGeom prst="line">
-            <a:avLst/>
-          </a:prstGeom>
-          <a:noFill/>
-          <a:ln w="19050">
-            <a:solidFill>
-              <a:srgbClr val="E67E22"/>
-            </a:solidFill>
-            <a:prstDash val="solid"/>
-          </a:ln>
-        </p:spPr>
-      </p:sp>
-      <p:sp>
-        <p:nvSpPr>
-          <p:cNvPr id="4" name="Shape 2"/>
-          <p:cNvSpPr/>
-          <p:nvPr/>
-        </p:nvSpPr>
-        <p:spPr>
-          <a:xfrm>
-            <a:off x="6492240" y="173736"/>
-            <a:ext cx="2286000" cy="502920"/>
+              <a:t>Reading: Week 31</a:t>
+            </a:r>
+            <a:endParaRPr lang="en-US" sz="2000" dirty="0"/>
+          </a:p>
+        </p:txBody>
+      </p:sp>
+      <p:sp>
+        <p:nvSpPr>
+          <p:cNvPr id="6" name="Text 4"/>
+          <p:cNvSpPr/>
+          <p:nvPr/>
+        </p:nvSpPr>
+        <p:spPr>
+          <a:xfrm>
+            <a:off x="365760" y="1508760"/>
+            <a:ext cx="8229600" cy="237744"/>
+          </a:xfrm>
+          <a:prstGeom prst="rect">
+            <a:avLst/>
+          </a:prstGeom>
+          <a:noFill/>
+          <a:ln/>
+        </p:spPr>
+        <p:txBody>
+          <a:bodyPr wrap="square" lIns="0" tIns="0" rIns="0" bIns="0" rtlCol="0" anchor="ctr"/>
+          <a:lstStyle/>
+          <a:p>
+            <a:pPr indent="0" marL="0">
+              <a:buNone/>
+            </a:pPr>
+            <a:r>
+              <a:rPr lang="en-US" sz="1100" b="1" spc="100" kern="0" dirty="0">
+                <a:solidFill>
+                  <a:srgbClr val="C7922C"/>
+                </a:solidFill>
+                <a:latin typeface="Calibri" pitchFamily="34" charset="0"/>
+                <a:ea typeface="Calibri" pitchFamily="34" charset="-122"/>
+                <a:cs typeface="Calibri" pitchFamily="34" charset="-120"/>
+              </a:rPr>
+              <a:t>BIG QUESTION</a:t>
+            </a:r>
+            <a:endParaRPr lang="en-US" sz="1100" dirty="0"/>
+          </a:p>
+        </p:txBody>
+      </p:sp>
+      <p:sp>
+        <p:nvSpPr>
+          <p:cNvPr id="7" name="Shape 5"/>
+          <p:cNvSpPr/>
+          <p:nvPr/>
+        </p:nvSpPr>
+        <p:spPr>
+          <a:xfrm>
+            <a:off x="365760" y="1746504"/>
+            <a:ext cx="8412480" cy="731520"/>
           </a:xfrm>
           <a:prstGeom prst="roundRect">
             <a:avLst>
-              <a:gd name="adj" fmla="val 21818"/>
-            </a:avLst>
-          </a:prstGeom>
-          <a:solidFill>
-            <a:srgbClr val="E67E22"/>
-          </a:solidFill>
-          <a:ln/>
-        </p:spPr>
-      </p:sp>
-      <p:sp>
-        <p:nvSpPr>
-          <p:cNvPr id="5" name="Text 3"/>
-          <p:cNvSpPr/>
-          <p:nvPr/>
-        </p:nvSpPr>
-        <p:spPr>
-          <a:xfrm>
-            <a:off x="6492240" y="173736"/>
-            <a:ext cx="2286000" cy="502920"/>
-          </a:xfrm>
-          <a:prstGeom prst="rect">
-            <a:avLst/>
-          </a:prstGeom>
-          <a:noFill/>
-          <a:ln/>
-        </p:spPr>
-        <p:txBody>
-          <a:bodyPr wrap="square" lIns="0" tIns="0" rIns="0" bIns="0" rtlCol="0" anchor="ctr"/>
-          <a:lstStyle/>
-          <a:p>
-            <a:pPr algn="ctr" indent="0" marL="0">
-              <a:buNone/>
-            </a:pPr>
-            <a:r>
-              <a:rPr lang="en-US" sz="1100" b="1" dirty="0">
-                <a:solidFill>
-                  <a:srgbClr val="0E1C42"/>
-                </a:solidFill>
-                <a:latin typeface="Calibri" pitchFamily="34" charset="0"/>
-                <a:ea typeface="Calibri" pitchFamily="34" charset="-122"/>
-                <a:cs typeface="Calibri" pitchFamily="34" charset="-120"/>
-              </a:rPr>
-              <a:t>CHAT PROMPT</a:t>
-            </a:r>
-            <a:endParaRPr lang="en-US" sz="1100" dirty="0"/>
-          </a:p>
-        </p:txBody>
-      </p:sp>
-      <p:sp>
-        <p:nvSpPr>
-          <p:cNvPr id="6" name="Text 4"/>
-          <p:cNvSpPr/>
-          <p:nvPr/>
-        </p:nvSpPr>
-        <p:spPr>
-          <a:xfrm>
-            <a:off x="457200" y="914400"/>
-            <a:ext cx="8046720" cy="292608"/>
-          </a:xfrm>
-          <a:prstGeom prst="rect">
-            <a:avLst/>
-          </a:prstGeom>
-          <a:noFill/>
-          <a:ln/>
-        </p:spPr>
-        <p:txBody>
-          <a:bodyPr wrap="square" lIns="0" tIns="0" rIns="0" bIns="0" rtlCol="0" anchor="ctr"/>
-          <a:lstStyle/>
-          <a:p>
-            <a:pPr indent="0" marL="0">
-              <a:buNone/>
-            </a:pPr>
-            <a:r>
-              <a:rPr lang="en-US" sz="1100" b="1" spc="200" kern="0" dirty="0">
-                <a:solidFill>
-                  <a:srgbClr val="C7922C"/>
-                </a:solidFill>
-                <a:latin typeface="Calibri" pitchFamily="34" charset="0"/>
-                <a:ea typeface="Calibri" pitchFamily="34" charset="-122"/>
-                <a:cs typeface="Calibri" pitchFamily="34" charset="-120"/>
-              </a:rPr>
-              <a:t>BIG QUESTION</a:t>
-            </a:r>
-            <a:endParaRPr lang="en-US" sz="1100" dirty="0"/>
-          </a:p>
-        </p:txBody>
-      </p:sp>
-      <p:sp>
-        <p:nvSpPr>
-          <p:cNvPr id="7" name="Shape 5"/>
-          <p:cNvSpPr/>
-          <p:nvPr/>
-        </p:nvSpPr>
-        <p:spPr>
-          <a:xfrm>
-            <a:off x="457200" y="1234440"/>
-            <a:ext cx="8229600" cy="640080"/>
-          </a:xfrm>
-          <a:prstGeom prst="roundRect">
-            <a:avLst>
-              <a:gd name="adj" fmla="val 14286"/>
+              <a:gd name="adj" fmla="val 12500"/>
             </a:avLst>
           </a:prstGeom>
           <a:solidFill>
             <a:srgbClr val="FEF6E8"/>
           </a:solidFill>
-          <a:ln w="12700">
+          <a:ln w="19050">
             <a:solidFill>
               <a:srgbClr val="C7922C"/>
             </a:solidFill>
@@ -4024,8 +3598,8 @@
         </p:nvSpPr>
         <p:spPr>
           <a:xfrm>
-            <a:off x="640080" y="1344168"/>
-            <a:ext cx="7863840" cy="411480"/>
+            <a:off x="594360" y="1874520"/>
+            <a:ext cx="7955280" cy="475488"/>
           </a:xfrm>
           <a:prstGeom prst="rect">
             <a:avLst/>
@@ -4041,7 +3615,7 @@
               <a:buNone/>
             </a:pPr>
             <a:r>
-              <a:rPr lang="en-US" sz="1800" i="1" dirty="0">
+              <a:rPr lang="en-US" sz="1700" dirty="0">
                 <a:solidFill>
                   <a:srgbClr val="1E293B"/>
                 </a:solidFill>
@@ -4051,43 +3625,48 @@
               </a:rPr>
               <a:t>Compare how two authors present the same topic or theme.</a:t>
             </a:r>
-            <a:endParaRPr lang="en-US" sz="1800" dirty="0"/>
-          </a:p>
-        </p:txBody>
-      </p:sp>
-      <p:sp>
-        <p:nvSpPr>
-          <p:cNvPr id="9" name="Shape 7"/>
-          <p:cNvSpPr/>
-          <p:nvPr/>
-        </p:nvSpPr>
-        <p:spPr>
-          <a:xfrm>
-            <a:off x="457200" y="1965960"/>
-            <a:ext cx="8229600" cy="640080"/>
-          </a:xfrm>
-          <a:prstGeom prst="roundRect">
-            <a:avLst>
-              <a:gd name="adj" fmla="val 14286"/>
-            </a:avLst>
-          </a:prstGeom>
-          <a:solidFill>
-            <a:srgbClr val="FEF6E8"/>
-          </a:solidFill>
-          <a:ln w="12700">
-            <a:solidFill>
-              <a:srgbClr val="C7922C"/>
-            </a:solidFill>
-            <a:prstDash val="solid"/>
-          </a:ln>
-          <a:effectLst>
-            <a:outerShdw sx="100000" sy="100000" kx="0" ky="0" algn="bl" rotWithShape="0" blurRad="101600" dist="38100" dir="2700000">
-              <a:srgbClr val="000000">
-                <a:alpha val="12000"/>
-              </a:srgbClr>
-            </a:outerShdw>
-          </a:effectLst>
-        </p:spPr>
+            <a:endParaRPr lang="en-US" sz="1700" dirty="0"/>
+          </a:p>
+        </p:txBody>
+      </p:sp>
+      <p:sp>
+        <p:nvSpPr>
+          <p:cNvPr id="9" name="Text 7"/>
+          <p:cNvSpPr/>
+          <p:nvPr/>
+        </p:nvSpPr>
+        <p:spPr>
+          <a:xfrm>
+            <a:off x="365760" y="2606040"/>
+            <a:ext cx="8229600" cy="237744"/>
+          </a:xfrm>
+          <a:prstGeom prst="rect">
+            <a:avLst/>
+          </a:prstGeom>
+          <a:noFill/>
+          <a:ln/>
+        </p:spPr>
+        <p:txBody>
+          <a:bodyPr wrap="square" lIns="0" tIns="0" rIns="0" bIns="0" rtlCol="0" anchor="ctr"/>
+          <a:lstStyle/>
+          <a:p>
+            <a:pPr indent="0" marL="0">
+              <a:buNone/>
+            </a:pPr>
+            <a:r>
+              <a:rPr lang="en-US" sz="1100" b="1" spc="100" kern="0" dirty="0">
+                <a:solidFill>
+                  <a:srgbClr val="55C8E8"/>
+                </a:solidFill>
+                <a:latin typeface="Calibri" pitchFamily="34" charset="0"/>
+                <a:ea typeface="Calibri" pitchFamily="34" charset="-122"/>
+                <a:cs typeface="Calibri" pitchFamily="34" charset="-120"/>
+              </a:rPr>
+              <a:t>READING LENS</a:t>
+            </a:r>
+            <a:endParaRPr lang="en-US" sz="1100" dirty="0"/>
+          </a:p>
+        </p:txBody>
       </p:sp>
       <p:sp>
         <p:nvSpPr>
@@ -4097,159 +3676,8 @@
         </p:nvSpPr>
         <p:spPr>
           <a:xfrm>
-            <a:off x="640080" y="2075688"/>
-            <a:ext cx="7863840" cy="411480"/>
-          </a:xfrm>
-          <a:prstGeom prst="rect">
-            <a:avLst/>
-          </a:prstGeom>
-          <a:noFill/>
-          <a:ln/>
-        </p:spPr>
-        <p:txBody>
-          <a:bodyPr wrap="square" lIns="0" tIns="0" rIns="0" bIns="0" rtlCol="0" anchor="ctr"/>
-          <a:lstStyle/>
-          <a:p>
-            <a:pPr indent="0" marL="0">
-              <a:buNone/>
-            </a:pPr>
-            <a:r>
-              <a:rPr lang="en-US" sz="1800" i="1" dirty="0">
-                <a:solidFill>
-                  <a:srgbClr val="1E293B"/>
-                </a:solidFill>
-                <a:latin typeface="Calibri" pitchFamily="34" charset="0"/>
-                <a:ea typeface="Calibri" pitchFamily="34" charset="-122"/>
-                <a:cs typeface="Calibri" pitchFamily="34" charset="-120"/>
-              </a:rPr>
-              <a:t>As you read today, ask yourself: After a whole year of reading, what do you think courage really means — and which story taught you the most about it?</a:t>
-            </a:r>
-            <a:endParaRPr lang="en-US" sz="1800" dirty="0"/>
-          </a:p>
-        </p:txBody>
-      </p:sp>
-      <p:sp>
-        <p:nvSpPr>
-          <p:cNvPr id="11" name="Shape 9"/>
-          <p:cNvSpPr/>
-          <p:nvPr/>
-        </p:nvSpPr>
-        <p:spPr>
-          <a:xfrm>
-            <a:off x="457200" y="2697480"/>
-            <a:ext cx="8229600" cy="640080"/>
-          </a:xfrm>
-          <a:prstGeom prst="roundRect">
-            <a:avLst>
-              <a:gd name="adj" fmla="val 14286"/>
-            </a:avLst>
-          </a:prstGeom>
-          <a:solidFill>
-            <a:srgbClr val="FEF6E8"/>
-          </a:solidFill>
-          <a:ln w="12700">
-            <a:solidFill>
-              <a:srgbClr val="C7922C"/>
-            </a:solidFill>
-            <a:prstDash val="solid"/>
-          </a:ln>
-          <a:effectLst>
-            <a:outerShdw sx="100000" sy="100000" kx="0" ky="0" algn="bl" rotWithShape="0" blurRad="101600" dist="38100" dir="2700000">
-              <a:srgbClr val="000000">
-                <a:alpha val="12000"/>
-              </a:srgbClr>
-            </a:outerShdw>
-          </a:effectLst>
-        </p:spPr>
-      </p:sp>
-      <p:sp>
-        <p:nvSpPr>
-          <p:cNvPr id="12" name="Text 10"/>
-          <p:cNvSpPr/>
-          <p:nvPr/>
-        </p:nvSpPr>
-        <p:spPr>
-          <a:xfrm>
-            <a:off x="640080" y="2807208"/>
-            <a:ext cx="7863840" cy="411480"/>
-          </a:xfrm>
-          <a:prstGeom prst="rect">
-            <a:avLst/>
-          </a:prstGeom>
-          <a:noFill/>
-          <a:ln/>
-        </p:spPr>
-        <p:txBody>
-          <a:bodyPr wrap="square" lIns="0" tIns="0" rIns="0" bIns="0" rtlCol="0" anchor="ctr"/>
-          <a:lstStyle/>
-          <a:p>
-            <a:pPr indent="0" marL="0">
-              <a:buNone/>
-            </a:pPr>
-            <a:r>
-              <a:rPr lang="en-US" sz="1800" i="1" dirty="0">
-                <a:solidFill>
-                  <a:srgbClr val="1E293B"/>
-                </a:solidFill>
-                <a:latin typeface="Calibri" pitchFamily="34" charset="0"/>
-                <a:ea typeface="Calibri" pitchFamily="34" charset="-122"/>
-                <a:cs typeface="Calibri" pitchFamily="34" charset="-120"/>
-              </a:rPr>
-              <a:t>Write your closing paragraph. Restate your claim about courage in a new way, and explain what you take away from reading both texts.</a:t>
-            </a:r>
-            <a:endParaRPr lang="en-US" sz="1800" dirty="0"/>
-          </a:p>
-        </p:txBody>
-      </p:sp>
-      <p:sp>
-        <p:nvSpPr>
-          <p:cNvPr id="13" name="Text 11"/>
-          <p:cNvSpPr/>
-          <p:nvPr/>
-        </p:nvSpPr>
-        <p:spPr>
-          <a:xfrm>
-            <a:off x="457200" y="3429000"/>
-            <a:ext cx="8046720" cy="292608"/>
-          </a:xfrm>
-          <a:prstGeom prst="rect">
-            <a:avLst/>
-          </a:prstGeom>
-          <a:noFill/>
-          <a:ln/>
-        </p:spPr>
-        <p:txBody>
-          <a:bodyPr wrap="square" lIns="0" tIns="0" rIns="0" bIns="0" rtlCol="0" anchor="ctr"/>
-          <a:lstStyle/>
-          <a:p>
-            <a:pPr indent="0" marL="0">
-              <a:buNone/>
-            </a:pPr>
-            <a:r>
-              <a:rPr lang="en-US" sz="1100" b="1" spc="200" kern="0" dirty="0">
-                <a:solidFill>
-                  <a:srgbClr val="8B6FC0"/>
-                </a:solidFill>
-                <a:latin typeface="Calibri" pitchFamily="34" charset="0"/>
-                <a:ea typeface="Calibri" pitchFamily="34" charset="-122"/>
-                <a:cs typeface="Calibri" pitchFamily="34" charset="-120"/>
-              </a:rPr>
-              <a:t>READING LENS</a:t>
-            </a:r>
-            <a:endParaRPr lang="en-US" sz="1100" dirty="0"/>
-          </a:p>
-        </p:txBody>
-      </p:sp>
-      <p:sp>
-        <p:nvSpPr>
-          <p:cNvPr id="14" name="Text 12"/>
-          <p:cNvSpPr/>
-          <p:nvPr/>
-        </p:nvSpPr>
-        <p:spPr>
-          <a:xfrm>
-            <a:off x="640080" y="3749040"/>
-            <a:ext cx="7863840" cy="731520"/>
+            <a:off x="365760" y="2843784"/>
+            <a:ext cx="8412480" cy="914400"/>
           </a:xfrm>
           <a:prstGeom prst="rect">
             <a:avLst/>
@@ -4313,14 +3741,34 @@
       </p:grpSpPr>
       <p:sp>
         <p:nvSpPr>
-          <p:cNvPr id="2" name="Text 0"/>
-          <p:cNvSpPr/>
-          <p:nvPr/>
-        </p:nvSpPr>
-        <p:spPr>
-          <a:xfrm>
-            <a:off x="365760" y="164592"/>
-            <a:ext cx="8412480" cy="566928"/>
+          <p:cNvPr id="2" name="Shape 0"/>
+          <p:cNvSpPr/>
+          <p:nvPr/>
+        </p:nvSpPr>
+        <p:spPr>
+          <a:xfrm>
+            <a:off x="0" y="0"/>
+            <a:ext cx="9144000" cy="566928"/>
+          </a:xfrm>
+          <a:prstGeom prst="rect">
+            <a:avLst/>
+          </a:prstGeom>
+          <a:solidFill>
+            <a:srgbClr val="55C8E8"/>
+          </a:solidFill>
+          <a:ln/>
+        </p:spPr>
+      </p:sp>
+      <p:sp>
+        <p:nvSpPr>
+          <p:cNvPr id="3" name="Text 1"/>
+          <p:cNvSpPr/>
+          <p:nvPr/>
+        </p:nvSpPr>
+        <p:spPr>
+          <a:xfrm>
+            <a:off x="365760" y="54864"/>
+            <a:ext cx="8412480" cy="457200"/>
           </a:xfrm>
           <a:prstGeom prst="rect">
             <a:avLst/>
@@ -4332,46 +3780,23 @@
           <a:bodyPr wrap="square" lIns="0" tIns="0" rIns="0" bIns="0" rtlCol="0" anchor="ctr"/>
           <a:lstStyle/>
           <a:p>
-            <a:pPr algn="l" indent="0" marL="0">
-              <a:buNone/>
-            </a:pPr>
-            <a:r>
-              <a:rPr lang="en-US" sz="2800" b="1" dirty="0">
-                <a:solidFill>
-                  <a:srgbClr val="0E1C42"/>
-                </a:solidFill>
-                <a:latin typeface="Calibri" pitchFamily="34" charset="0"/>
-                <a:ea typeface="Calibri" pitchFamily="34" charset="-122"/>
-                <a:cs typeface="Calibri" pitchFamily="34" charset="-120"/>
-              </a:rPr>
-              <a:t>✅ Model Sentence — Study What's Right</a:t>
-            </a:r>
-            <a:endParaRPr lang="en-US" sz="2800" dirty="0"/>
-          </a:p>
-        </p:txBody>
-      </p:sp>
-      <p:sp>
-        <p:nvSpPr>
-          <p:cNvPr id="3" name="Shape 1"/>
-          <p:cNvSpPr/>
-          <p:nvPr/>
-        </p:nvSpPr>
-        <p:spPr>
-          <a:xfrm>
-            <a:off x="365760" y="749808"/>
-            <a:ext cx="8412480" cy="0"/>
-          </a:xfrm>
-          <a:prstGeom prst="line">
-            <a:avLst/>
-          </a:prstGeom>
-          <a:noFill/>
-          <a:ln w="19050">
-            <a:solidFill>
-              <a:srgbClr val="34B76F"/>
-            </a:solidFill>
-            <a:prstDash val="solid"/>
-          </a:ln>
-        </p:spPr>
+            <a:pPr indent="0" marL="0">
+              <a:buNone/>
+            </a:pPr>
+            <a:r>
+              <a:rPr lang="en-US" sz="2200" b="1" dirty="0">
+                <a:solidFill>
+                  <a:srgbClr val="FFFFFF"/>
+                </a:solidFill>
+                <a:latin typeface="Calibri" pitchFamily="34" charset="0"/>
+                <a:ea typeface="Calibri" pitchFamily="34" charset="-122"/>
+                <a:cs typeface="Calibri" pitchFamily="34" charset="-120"/>
+              </a:rPr>
+              <a:t>✏️  Daily Oral Language</a:t>
+            </a:r>
+            <a:endParaRPr lang="en-US" sz="2200" dirty="0"/>
+          </a:p>
+        </p:txBody>
       </p:sp>
       <p:sp>
         <p:nvSpPr>
@@ -4381,8 +3806,8 @@
         </p:nvSpPr>
         <p:spPr>
           <a:xfrm>
-            <a:off x="457200" y="1005840"/>
-            <a:ext cx="8046720" cy="292608"/>
+            <a:off x="365760" y="804672"/>
+            <a:ext cx="8229600" cy="237744"/>
           </a:xfrm>
           <a:prstGeom prst="rect">
             <a:avLst/>
@@ -4398,15 +3823,15 @@
               <a:buNone/>
             </a:pPr>
             <a:r>
-              <a:rPr lang="en-US" sz="1100" b="1" spc="200" kern="0" dirty="0">
-                <a:solidFill>
-                  <a:srgbClr val="34B76F"/>
-                </a:solidFill>
-                <a:latin typeface="Calibri" pitchFamily="34" charset="0"/>
-                <a:ea typeface="Calibri" pitchFamily="34" charset="-122"/>
-                <a:cs typeface="Calibri" pitchFamily="34" charset="-120"/>
-              </a:rPr>
-              <a:t>KEY GRAMMAR POINTS</a:t>
+              <a:rPr lang="en-US" sz="1100" b="1" spc="100" kern="0" dirty="0">
+                <a:solidFill>
+                  <a:srgbClr val="55C8E8"/>
+                </a:solidFill>
+                <a:latin typeface="Calibri" pitchFamily="34" charset="0"/>
+                <a:ea typeface="Calibri" pitchFamily="34" charset="-122"/>
+                <a:cs typeface="Calibri" pitchFamily="34" charset="-120"/>
+              </a:rPr>
+              <a:t>KEY GRAMMAR POINTS IN THE MODEL</a:t>
             </a:r>
             <a:endParaRPr lang="en-US" sz="1100" dirty="0"/>
           </a:p>
@@ -4420,16 +3845,16 @@
         </p:nvSpPr>
         <p:spPr>
           <a:xfrm>
-            <a:off x="457200" y="1371600"/>
-            <a:ext cx="8229600" cy="475488"/>
+            <a:off x="365760" y="1097280"/>
+            <a:ext cx="8412480" cy="548640"/>
           </a:xfrm>
           <a:prstGeom prst="roundRect">
             <a:avLst>
-              <a:gd name="adj" fmla="val 19231"/>
+              <a:gd name="adj" fmla="val 16667"/>
             </a:avLst>
           </a:prstGeom>
           <a:solidFill>
-            <a:srgbClr val="E8F8EF"/>
+            <a:srgbClr val="F8FAFC"/>
           </a:solidFill>
           <a:ln/>
           <a:effectLst>
@@ -4449,7 +3874,7 @@
         </p:nvSpPr>
         <p:spPr>
           <a:xfrm>
-            <a:off x="640080" y="1426464"/>
+            <a:off x="594360" y="1188720"/>
             <a:ext cx="7863840" cy="365760"/>
           </a:xfrm>
           <a:prstGeom prst="rect">
@@ -4466,7 +3891,7 @@
               <a:buNone/>
             </a:pPr>
             <a:r>
-              <a:rPr lang="en-US" sz="1600" b="1" dirty="0">
+              <a:rPr lang="en-US" sz="1500" b="1" dirty="0">
                 <a:solidFill>
                   <a:srgbClr val="0E1C42"/>
                 </a:solidFill>
@@ -4474,7 +3899,7 @@
                 <a:ea typeface="Calibri" pitchFamily="34" charset="-122"/>
                 <a:cs typeface="Calibri" pitchFamily="34" charset="-120"/>
               </a:rPr>
-              <a:t>Both</a:t>
+              <a:t>Both  </a:t>
             </a:r>
             <a:pPr indent="0" marL="0">
               <a:buNone/>
@@ -4482,15 +3907,15 @@
             <a:r>
               <a:rPr lang="en-US" sz="1300" dirty="0">
                 <a:solidFill>
-                  <a:srgbClr val="64748B"/>
-                </a:solidFill>
-                <a:latin typeface="Calibri" pitchFamily="34" charset="0"/>
-                <a:ea typeface="Calibri" pitchFamily="34" charset="-122"/>
-                <a:cs typeface="Calibri" pitchFamily="34" charset="-120"/>
-              </a:rPr>
-              <a:t>  —  Subject — refers to both authors.</a:t>
-            </a:r>
-            <a:endParaRPr lang="en-US" sz="1600" dirty="0"/>
+                  <a:srgbClr val="1E293B"/>
+                </a:solidFill>
+                <a:latin typeface="Calibri" pitchFamily="34" charset="0"/>
+                <a:ea typeface="Calibri" pitchFamily="34" charset="-122"/>
+                <a:cs typeface="Calibri" pitchFamily="34" charset="-120"/>
+              </a:rPr>
+              <a:t>Subject — refers to both authors.</a:t>
+            </a:r>
+            <a:endParaRPr lang="en-US" sz="1500" dirty="0"/>
           </a:p>
         </p:txBody>
       </p:sp>
@@ -4502,16 +3927,16 @@
         </p:nvSpPr>
         <p:spPr>
           <a:xfrm>
-            <a:off x="457200" y="1901952"/>
-            <a:ext cx="8229600" cy="475488"/>
+            <a:off x="365760" y="1719072"/>
+            <a:ext cx="8412480" cy="548640"/>
           </a:xfrm>
           <a:prstGeom prst="roundRect">
             <a:avLst>
-              <a:gd name="adj" fmla="val 19231"/>
+              <a:gd name="adj" fmla="val 16667"/>
             </a:avLst>
           </a:prstGeom>
           <a:solidFill>
-            <a:srgbClr val="E8F8EF"/>
+            <a:srgbClr val="FFFFFF"/>
           </a:solidFill>
           <a:ln/>
           <a:effectLst>
@@ -4531,7 +3956,7 @@
         </p:nvSpPr>
         <p:spPr>
           <a:xfrm>
-            <a:off x="640080" y="1956816"/>
+            <a:off x="594360" y="1810512"/>
             <a:ext cx="7863840" cy="365760"/>
           </a:xfrm>
           <a:prstGeom prst="rect">
@@ -4548,7 +3973,7 @@
               <a:buNone/>
             </a:pPr>
             <a:r>
-              <a:rPr lang="en-US" sz="1600" b="1" dirty="0">
+              <a:rPr lang="en-US" sz="1500" b="1" dirty="0">
                 <a:solidFill>
                   <a:srgbClr val="0E1C42"/>
                 </a:solidFill>
@@ -4556,7 +3981,7 @@
                 <a:ea typeface="Calibri" pitchFamily="34" charset="-122"/>
                 <a:cs typeface="Calibri" pitchFamily="34" charset="-120"/>
               </a:rPr>
-              <a:t>agree</a:t>
+              <a:t>agree  </a:t>
             </a:r>
             <a:pPr indent="0" marL="0">
               <a:buNone/>
@@ -4564,15 +3989,15 @@
             <a:r>
               <a:rPr lang="en-US" sz="1300" dirty="0">
                 <a:solidFill>
-                  <a:srgbClr val="64748B"/>
-                </a:solidFill>
-                <a:latin typeface="Calibri" pitchFamily="34" charset="0"/>
-                <a:ea typeface="Calibri" pitchFamily="34" charset="-122"/>
-                <a:cs typeface="Calibri" pitchFamily="34" charset="-120"/>
-              </a:rPr>
-              <a:t>  —  Present-tense verb — used for what a text argues.</a:t>
-            </a:r>
-            <a:endParaRPr lang="en-US" sz="1600" dirty="0"/>
+                  <a:srgbClr val="1E293B"/>
+                </a:solidFill>
+                <a:latin typeface="Calibri" pitchFamily="34" charset="0"/>
+                <a:ea typeface="Calibri" pitchFamily="34" charset="-122"/>
+                <a:cs typeface="Calibri" pitchFamily="34" charset="-120"/>
+              </a:rPr>
+              <a:t>Present-tense verb — used for what a text argues.</a:t>
+            </a:r>
+            <a:endParaRPr lang="en-US" sz="1500" dirty="0"/>
           </a:p>
         </p:txBody>
       </p:sp>
@@ -4584,16 +4009,16 @@
         </p:nvSpPr>
         <p:spPr>
           <a:xfrm>
-            <a:off x="457200" y="2432304"/>
-            <a:ext cx="8229600" cy="475488"/>
+            <a:off x="365760" y="2340864"/>
+            <a:ext cx="8412480" cy="548640"/>
           </a:xfrm>
           <a:prstGeom prst="roundRect">
             <a:avLst>
-              <a:gd name="adj" fmla="val 19231"/>
+              <a:gd name="adj" fmla="val 16667"/>
             </a:avLst>
           </a:prstGeom>
           <a:solidFill>
-            <a:srgbClr val="E8F8EF"/>
+            <a:srgbClr val="F8FAFC"/>
           </a:solidFill>
           <a:ln/>
           <a:effectLst>
@@ -4613,7 +4038,7 @@
         </p:nvSpPr>
         <p:spPr>
           <a:xfrm>
-            <a:off x="640080" y="2487168"/>
+            <a:off x="594360" y="2432304"/>
             <a:ext cx="7863840" cy="365760"/>
           </a:xfrm>
           <a:prstGeom prst="rect">
@@ -4630,7 +4055,7 @@
               <a:buNone/>
             </a:pPr>
             <a:r>
-              <a:rPr lang="en-US" sz="1600" b="1" dirty="0">
+              <a:rPr lang="en-US" sz="1500" b="1" dirty="0">
                 <a:solidFill>
                   <a:srgbClr val="0E1C42"/>
                 </a:solidFill>
@@ -4638,7 +4063,7 @@
                 <a:ea typeface="Calibri" pitchFamily="34" charset="-122"/>
                 <a:cs typeface="Calibri" pitchFamily="34" charset="-120"/>
               </a:rPr>
-              <a:t>feeling</a:t>
+              <a:t>feeling  </a:t>
             </a:r>
             <a:pPr indent="0" marL="0">
               <a:buNone/>
@@ -4646,15 +4071,15 @@
             <a:r>
               <a:rPr lang="en-US" sz="1300" dirty="0">
                 <a:solidFill>
-                  <a:srgbClr val="64748B"/>
-                </a:solidFill>
-                <a:latin typeface="Calibri" pitchFamily="34" charset="0"/>
-                <a:ea typeface="Calibri" pitchFamily="34" charset="-122"/>
-                <a:cs typeface="Calibri" pitchFamily="34" charset="-120"/>
-              </a:rPr>
-              <a:t>  —  Noun — contrast with the next noun.</a:t>
-            </a:r>
-            <a:endParaRPr lang="en-US" sz="1600" dirty="0"/>
+                  <a:srgbClr val="1E293B"/>
+                </a:solidFill>
+                <a:latin typeface="Calibri" pitchFamily="34" charset="0"/>
+                <a:ea typeface="Calibri" pitchFamily="34" charset="-122"/>
+                <a:cs typeface="Calibri" pitchFamily="34" charset="-120"/>
+              </a:rPr>
+              <a:t>Noun — contrast with the next noun.</a:t>
+            </a:r>
+            <a:endParaRPr lang="en-US" sz="1500" dirty="0"/>
           </a:p>
         </p:txBody>
       </p:sp>
@@ -4666,16 +4091,16 @@
         </p:nvSpPr>
         <p:spPr>
           <a:xfrm>
-            <a:off x="457200" y="2962656"/>
-            <a:ext cx="8229600" cy="475488"/>
+            <a:off x="365760" y="2962656"/>
+            <a:ext cx="8412480" cy="548640"/>
           </a:xfrm>
           <a:prstGeom prst="roundRect">
             <a:avLst>
-              <a:gd name="adj" fmla="val 19231"/>
+              <a:gd name="adj" fmla="val 16667"/>
             </a:avLst>
           </a:prstGeom>
           <a:solidFill>
-            <a:srgbClr val="E8F8EF"/>
+            <a:srgbClr val="FFFFFF"/>
           </a:solidFill>
           <a:ln/>
           <a:effectLst>
@@ -4695,7 +4120,7 @@
         </p:nvSpPr>
         <p:spPr>
           <a:xfrm>
-            <a:off x="640080" y="3017520"/>
+            <a:off x="594360" y="3054096"/>
             <a:ext cx="7863840" cy="365760"/>
           </a:xfrm>
           <a:prstGeom prst="rect">
@@ -4712,7 +4137,7 @@
               <a:buNone/>
             </a:pPr>
             <a:r>
-              <a:rPr lang="en-US" sz="1600" b="1" dirty="0">
+              <a:rPr lang="en-US" sz="1500" b="1" dirty="0">
                 <a:solidFill>
                   <a:srgbClr val="0E1C42"/>
                 </a:solidFill>
@@ -4720,7 +4145,7 @@
                 <a:ea typeface="Calibri" pitchFamily="34" charset="-122"/>
                 <a:cs typeface="Calibri" pitchFamily="34" charset="-120"/>
               </a:rPr>
-              <a:t>choice</a:t>
+              <a:t>choice  </a:t>
             </a:r>
             <a:pPr indent="0" marL="0">
               <a:buNone/>
@@ -4728,97 +4153,15 @@
             <a:r>
               <a:rPr lang="en-US" sz="1300" dirty="0">
                 <a:solidFill>
-                  <a:srgbClr val="64748B"/>
-                </a:solidFill>
-                <a:latin typeface="Calibri" pitchFamily="34" charset="0"/>
-                <a:ea typeface="Calibri" pitchFamily="34" charset="-122"/>
-                <a:cs typeface="Calibri" pitchFamily="34" charset="-120"/>
-              </a:rPr>
-              <a:t>  —  Noun — the central idea of both texts.</a:t>
-            </a:r>
-            <a:endParaRPr lang="en-US" sz="1600" dirty="0"/>
-          </a:p>
-        </p:txBody>
-      </p:sp>
-      <p:sp>
-        <p:nvSpPr>
-          <p:cNvPr id="13" name="Shape 11"/>
-          <p:cNvSpPr/>
-          <p:nvPr/>
-        </p:nvSpPr>
-        <p:spPr>
-          <a:xfrm>
-            <a:off x="457200" y="3493008"/>
-            <a:ext cx="8229600" cy="475488"/>
-          </a:xfrm>
-          <a:prstGeom prst="roundRect">
-            <a:avLst>
-              <a:gd name="adj" fmla="val 19231"/>
-            </a:avLst>
-          </a:prstGeom>
-          <a:solidFill>
-            <a:srgbClr val="E8F8EF"/>
-          </a:solidFill>
-          <a:ln/>
-          <a:effectLst>
-            <a:outerShdw sx="100000" sy="100000" kx="0" ky="0" algn="bl" rotWithShape="0" blurRad="101600" dist="38100" dir="2700000">
-              <a:srgbClr val="000000">
-                <a:alpha val="12000"/>
-              </a:srgbClr>
-            </a:outerShdw>
-          </a:effectLst>
-        </p:spPr>
-      </p:sp>
-      <p:sp>
-        <p:nvSpPr>
-          <p:cNvPr id="14" name="Text 12"/>
-          <p:cNvSpPr/>
-          <p:nvPr/>
-        </p:nvSpPr>
-        <p:spPr>
-          <a:xfrm>
-            <a:off x="640080" y="3547872"/>
-            <a:ext cx="7863840" cy="365760"/>
-          </a:xfrm>
-          <a:prstGeom prst="rect">
-            <a:avLst/>
-          </a:prstGeom>
-          <a:noFill/>
-          <a:ln/>
-        </p:spPr>
-        <p:txBody>
-          <a:bodyPr wrap="square" lIns="0" tIns="0" rIns="0" bIns="0" rtlCol="0" anchor="ctr"/>
-          <a:lstStyle/>
-          <a:p>
-            <a:pPr indent="0" marL="0">
-              <a:buNone/>
-            </a:pPr>
-            <a:r>
-              <a:rPr lang="en-US" sz="1600" b="1" dirty="0">
-                <a:solidFill>
-                  <a:srgbClr val="0E1C42"/>
-                </a:solidFill>
-                <a:latin typeface="Calibri" pitchFamily="34" charset="0"/>
-                <a:ea typeface="Calibri" pitchFamily="34" charset="-122"/>
-                <a:cs typeface="Calibri" pitchFamily="34" charset="-120"/>
-              </a:rPr>
-              <a:t>lifetime.</a:t>
-            </a:r>
-            <a:pPr indent="0" marL="0">
-              <a:buNone/>
-            </a:pPr>
-            <a:r>
-              <a:rPr lang="en-US" sz="1300" dirty="0">
-                <a:solidFill>
-                  <a:srgbClr val="64748B"/>
-                </a:solidFill>
-                <a:latin typeface="Calibri" pitchFamily="34" charset="0"/>
-                <a:ea typeface="Calibri" pitchFamily="34" charset="-122"/>
-                <a:cs typeface="Calibri" pitchFamily="34" charset="-120"/>
-              </a:rPr>
-              <a:t>  —  Period — ends the sentence.</a:t>
-            </a:r>
-            <a:endParaRPr lang="en-US" sz="1600" dirty="0"/>
+                  <a:srgbClr val="1E293B"/>
+                </a:solidFill>
+                <a:latin typeface="Calibri" pitchFamily="34" charset="0"/>
+                <a:ea typeface="Calibri" pitchFamily="34" charset="-122"/>
+                <a:cs typeface="Calibri" pitchFamily="34" charset="-120"/>
+              </a:rPr>
+              <a:t>Noun — the central idea of both texts.</a:t>
+            </a:r>
+            <a:endParaRPr lang="en-US" sz="1500" dirty="0"/>
           </a:p>
         </p:txBody>
       </p:sp>
@@ -4836,7 +4179,7 @@
     <p:bg>
       <p:bgPr>
         <a:solidFill>
-          <a:srgbClr val="E5F7FC"/>
+          <a:srgbClr val="F8FAFC"/>
         </a:solidFill>
       </p:bgPr>
     </p:bg>
@@ -4856,14 +4199,34 @@
       </p:grpSpPr>
       <p:sp>
         <p:nvSpPr>
-          <p:cNvPr id="2" name="Text 0"/>
-          <p:cNvSpPr/>
-          <p:nvPr/>
-        </p:nvSpPr>
-        <p:spPr>
-          <a:xfrm>
-            <a:off x="365760" y="164592"/>
-            <a:ext cx="5943600" cy="566928"/>
+          <p:cNvPr id="2" name="Shape 0"/>
+          <p:cNvSpPr/>
+          <p:nvPr/>
+        </p:nvSpPr>
+        <p:spPr>
+          <a:xfrm>
+            <a:off x="0" y="0"/>
+            <a:ext cx="9144000" cy="566928"/>
+          </a:xfrm>
+          <a:prstGeom prst="rect">
+            <a:avLst/>
+          </a:prstGeom>
+          <a:solidFill>
+            <a:srgbClr val="55C8E8"/>
+          </a:solidFill>
+          <a:ln/>
+        </p:spPr>
+      </p:sp>
+      <p:sp>
+        <p:nvSpPr>
+          <p:cNvPr id="3" name="Text 1"/>
+          <p:cNvSpPr/>
+          <p:nvPr/>
+        </p:nvSpPr>
+        <p:spPr>
+          <a:xfrm>
+            <a:off x="365760" y="54864"/>
+            <a:ext cx="8412480" cy="457200"/>
           </a:xfrm>
           <a:prstGeom prst="rect">
             <a:avLst/>
@@ -4875,130 +4238,85 @@
           <a:bodyPr wrap="square" lIns="0" tIns="0" rIns="0" bIns="0" rtlCol="0" anchor="ctr"/>
           <a:lstStyle/>
           <a:p>
-            <a:pPr algn="l" indent="0" marL="0">
-              <a:buNone/>
-            </a:pPr>
-            <a:r>
-              <a:rPr lang="en-US" sz="2800" b="1" dirty="0">
-                <a:solidFill>
-                  <a:srgbClr val="0E1C42"/>
-                </a:solidFill>
-                <a:latin typeface="Calibri" pitchFamily="34" charset="0"/>
-                <a:ea typeface="Calibri" pitchFamily="34" charset="-122"/>
-                <a:cs typeface="Calibri" pitchFamily="34" charset="-120"/>
-              </a:rPr>
-              <a:t>🔧 Fix-It Sentence — Now You Try</a:t>
-            </a:r>
-            <a:endParaRPr lang="en-US" sz="2800" dirty="0"/>
-          </a:p>
-        </p:txBody>
-      </p:sp>
-      <p:sp>
-        <p:nvSpPr>
-          <p:cNvPr id="3" name="Shape 1"/>
+            <a:pPr indent="0" marL="0">
+              <a:buNone/>
+            </a:pPr>
+            <a:r>
+              <a:rPr lang="en-US" sz="2200" b="1" dirty="0">
+                <a:solidFill>
+                  <a:srgbClr val="FFFFFF"/>
+                </a:solidFill>
+                <a:latin typeface="Calibri" pitchFamily="34" charset="0"/>
+                <a:ea typeface="Calibri" pitchFamily="34" charset="-122"/>
+                <a:cs typeface="Calibri" pitchFamily="34" charset="-120"/>
+              </a:rPr>
+              <a:t>✏️  Daily Oral Language</a:t>
+            </a:r>
+            <a:endParaRPr lang="en-US" sz="2200" dirty="0"/>
+          </a:p>
+        </p:txBody>
+      </p:sp>
+      <p:sp>
+        <p:nvSpPr>
+          <p:cNvPr id="4" name="Text 2"/>
           <p:cNvSpPr/>
           <p:nvPr/>
         </p:nvSpPr>
         <p:spPr>
           <a:xfrm>
             <a:off x="365760" y="749808"/>
-            <a:ext cx="8412480" cy="0"/>
-          </a:xfrm>
-          <a:prstGeom prst="line">
-            <a:avLst/>
-          </a:prstGeom>
-          <a:noFill/>
+            <a:ext cx="8229600" cy="237744"/>
+          </a:xfrm>
+          <a:prstGeom prst="rect">
+            <a:avLst/>
+          </a:prstGeom>
+          <a:noFill/>
+          <a:ln/>
+        </p:spPr>
+        <p:txBody>
+          <a:bodyPr wrap="square" lIns="0" tIns="0" rIns="0" bIns="0" rtlCol="0" anchor="ctr"/>
+          <a:lstStyle/>
+          <a:p>
+            <a:pPr indent="0" marL="0">
+              <a:buNone/>
+            </a:pPr>
+            <a:r>
+              <a:rPr lang="en-US" sz="1100" b="1" spc="100" kern="0" dirty="0">
+                <a:solidFill>
+                  <a:srgbClr val="55C8E8"/>
+                </a:solidFill>
+                <a:latin typeface="Calibri" pitchFamily="34" charset="0"/>
+                <a:ea typeface="Calibri" pitchFamily="34" charset="-122"/>
+                <a:cs typeface="Calibri" pitchFamily="34" charset="-120"/>
+              </a:rPr>
+              <a:t>NOW FIX THIS ONE</a:t>
+            </a:r>
+            <a:endParaRPr lang="en-US" sz="1100" dirty="0"/>
+          </a:p>
+        </p:txBody>
+      </p:sp>
+      <p:sp>
+        <p:nvSpPr>
+          <p:cNvPr id="5" name="Shape 3"/>
+          <p:cNvSpPr/>
+          <p:nvPr/>
+        </p:nvSpPr>
+        <p:spPr>
+          <a:xfrm>
+            <a:off x="365760" y="1024128"/>
+            <a:ext cx="8412480" cy="777240"/>
+          </a:xfrm>
+          <a:prstGeom prst="roundRect">
+            <a:avLst>
+              <a:gd name="adj" fmla="val 11765"/>
+            </a:avLst>
+          </a:prstGeom>
+          <a:solidFill>
+            <a:srgbClr val="FFFFFF"/>
+          </a:solidFill>
           <a:ln w="19050">
             <a:solidFill>
-              <a:srgbClr val="E67E22"/>
-            </a:solidFill>
-            <a:prstDash val="solid"/>
-          </a:ln>
-        </p:spPr>
-      </p:sp>
-      <p:sp>
-        <p:nvSpPr>
-          <p:cNvPr id="4" name="Shape 2"/>
-          <p:cNvSpPr/>
-          <p:nvPr/>
-        </p:nvSpPr>
-        <p:spPr>
-          <a:xfrm>
-            <a:off x="6492240" y="173736"/>
-            <a:ext cx="2286000" cy="502920"/>
-          </a:xfrm>
-          <a:prstGeom prst="roundRect">
-            <a:avLst>
-              <a:gd name="adj" fmla="val 21818"/>
-            </a:avLst>
-          </a:prstGeom>
-          <a:solidFill>
-            <a:srgbClr val="E67E22"/>
-          </a:solidFill>
-          <a:ln/>
-        </p:spPr>
-      </p:sp>
-      <p:sp>
-        <p:nvSpPr>
-          <p:cNvPr id="5" name="Text 3"/>
-          <p:cNvSpPr/>
-          <p:nvPr/>
-        </p:nvSpPr>
-        <p:spPr>
-          <a:xfrm>
-            <a:off x="6492240" y="173736"/>
-            <a:ext cx="2286000" cy="502920"/>
-          </a:xfrm>
-          <a:prstGeom prst="rect">
-            <a:avLst/>
-          </a:prstGeom>
-          <a:noFill/>
-          <a:ln/>
-        </p:spPr>
-        <p:txBody>
-          <a:bodyPr wrap="square" lIns="0" tIns="0" rIns="0" bIns="0" rtlCol="0" anchor="ctr"/>
-          <a:lstStyle/>
-          <a:p>
-            <a:pPr algn="ctr" indent="0" marL="0">
-              <a:buNone/>
-            </a:pPr>
-            <a:r>
-              <a:rPr lang="en-US" sz="1100" b="1" dirty="0">
-                <a:solidFill>
-                  <a:srgbClr val="0E1C42"/>
-                </a:solidFill>
-                <a:latin typeface="Calibri" pitchFamily="34" charset="0"/>
-                <a:ea typeface="Calibri" pitchFamily="34" charset="-122"/>
-                <a:cs typeface="Calibri" pitchFamily="34" charset="-120"/>
-              </a:rPr>
-              <a:t>CHAT PROMPT</a:t>
-            </a:r>
-            <a:endParaRPr lang="en-US" sz="1100" dirty="0"/>
-          </a:p>
-        </p:txBody>
-      </p:sp>
-      <p:sp>
-        <p:nvSpPr>
-          <p:cNvPr id="6" name="Shape 4"/>
-          <p:cNvSpPr/>
-          <p:nvPr/>
-        </p:nvSpPr>
-        <p:spPr>
-          <a:xfrm>
-            <a:off x="457200" y="1005840"/>
-            <a:ext cx="8229600" cy="640080"/>
-          </a:xfrm>
-          <a:prstGeom prst="roundRect">
-            <a:avLst>
-              <a:gd name="adj" fmla="val 14286"/>
-            </a:avLst>
-          </a:prstGeom>
-          <a:solidFill>
-            <a:srgbClr val="F8FAFC"/>
-          </a:solidFill>
-          <a:ln w="12700">
-            <a:solidFill>
-              <a:srgbClr val="C7922C"/>
+              <a:srgbClr val="55C8E8"/>
             </a:solidFill>
             <a:prstDash val="solid"/>
           </a:ln>
@@ -5013,14 +4331,53 @@
       </p:sp>
       <p:sp>
         <p:nvSpPr>
+          <p:cNvPr id="6" name="Text 4"/>
+          <p:cNvSpPr/>
+          <p:nvPr/>
+        </p:nvSpPr>
+        <p:spPr>
+          <a:xfrm>
+            <a:off x="594360" y="1152144"/>
+            <a:ext cx="7955280" cy="521208"/>
+          </a:xfrm>
+          <a:prstGeom prst="rect">
+            <a:avLst/>
+          </a:prstGeom>
+          <a:noFill/>
+          <a:ln/>
+        </p:spPr>
+        <p:txBody>
+          <a:bodyPr wrap="square" lIns="0" tIns="0" rIns="0" bIns="0" rtlCol="0" anchor="ctr"/>
+          <a:lstStyle/>
+          <a:p>
+            <a:pPr indent="0" marL="0">
+              <a:buNone/>
+            </a:pPr>
+            <a:r>
+              <a:rPr lang="en-US" sz="1700" dirty="0">
+                <a:solidFill>
+                  <a:srgbClr val="1E293B"/>
+                </a:solidFill>
+                <a:latin typeface="Calibri" pitchFamily="34" charset="0"/>
+                <a:ea typeface="Calibri" pitchFamily="34" charset="-122"/>
+                <a:cs typeface="Calibri" pitchFamily="34" charset="-120"/>
+              </a:rPr>
+              <a:t>after reading both texts i believe that courage is something every character we read about this year had to find inside themselves</a:t>
+            </a:r>
+            <a:endParaRPr lang="en-US" sz="1700" dirty="0"/>
+          </a:p>
+        </p:txBody>
+      </p:sp>
+      <p:sp>
+        <p:nvSpPr>
           <p:cNvPr id="7" name="Text 5"/>
           <p:cNvSpPr/>
           <p:nvPr/>
         </p:nvSpPr>
         <p:spPr>
           <a:xfrm>
-            <a:off x="640080" y="1115568"/>
-            <a:ext cx="7863840" cy="411480"/>
+            <a:off x="365760" y="2788920"/>
+            <a:ext cx="8412480" cy="365760"/>
           </a:xfrm>
           <a:prstGeom prst="rect">
             <a:avLst/>
@@ -5036,17 +4393,17 @@
               <a:buNone/>
             </a:pPr>
             <a:r>
-              <a:rPr lang="en-US" sz="1800" i="1" dirty="0">
-                <a:solidFill>
-                  <a:srgbClr val="1E293B"/>
-                </a:solidFill>
-                <a:latin typeface="Calibri" pitchFamily="34" charset="0"/>
-                <a:ea typeface="Calibri" pitchFamily="34" charset="-122"/>
-                <a:cs typeface="Calibri" pitchFamily="34" charset="-120"/>
-              </a:rPr>
-              <a:t>after reading both texts i believe that courage is something every character we read about this year had to find inside themselves</a:t>
-            </a:r>
-            <a:endParaRPr lang="en-US" sz="1800" dirty="0"/>
+              <a:rPr lang="en-US" sz="1600" b="1" dirty="0">
+                <a:solidFill>
+                  <a:srgbClr val="0E1C42"/>
+                </a:solidFill>
+                <a:latin typeface="Calibri" pitchFamily="34" charset="0"/>
+                <a:ea typeface="Calibri" pitchFamily="34" charset="-122"/>
+                <a:cs typeface="Calibri" pitchFamily="34" charset="-120"/>
+              </a:rPr>
+              <a:t>Rewrite the sentence correctly in your notebook.</a:t>
+            </a:r>
+            <a:endParaRPr lang="en-US" sz="1600" dirty="0"/>
           </a:p>
         </p:txBody>
       </p:sp>
@@ -5064,7 +4421,7 @@
     <p:bg>
       <p:bgPr>
         <a:solidFill>
-          <a:srgbClr val="E5F7FC"/>
+          <a:srgbClr val="F8FAFC"/>
         </a:solidFill>
       </p:bgPr>
     </p:bg>
@@ -5084,14 +4441,34 @@
       </p:grpSpPr>
       <p:sp>
         <p:nvSpPr>
-          <p:cNvPr id="2" name="Text 0"/>
-          <p:cNvSpPr/>
-          <p:nvPr/>
-        </p:nvSpPr>
-        <p:spPr>
-          <a:xfrm>
-            <a:off x="365760" y="164592"/>
-            <a:ext cx="5943600" cy="566928"/>
+          <p:cNvPr id="2" name="Shape 0"/>
+          <p:cNvSpPr/>
+          <p:nvPr/>
+        </p:nvSpPr>
+        <p:spPr>
+          <a:xfrm>
+            <a:off x="0" y="0"/>
+            <a:ext cx="9144000" cy="566928"/>
+          </a:xfrm>
+          <a:prstGeom prst="rect">
+            <a:avLst/>
+          </a:prstGeom>
+          <a:solidFill>
+            <a:srgbClr val="55C8E8"/>
+          </a:solidFill>
+          <a:ln/>
+        </p:spPr>
+      </p:sp>
+      <p:sp>
+        <p:nvSpPr>
+          <p:cNvPr id="3" name="Text 1"/>
+          <p:cNvSpPr/>
+          <p:nvPr/>
+        </p:nvSpPr>
+        <p:spPr>
+          <a:xfrm>
+            <a:off x="365760" y="54864"/>
+            <a:ext cx="8412480" cy="457200"/>
           </a:xfrm>
           <a:prstGeom prst="rect">
             <a:avLst/>
@@ -5103,130 +4480,85 @@
           <a:bodyPr wrap="square" lIns="0" tIns="0" rIns="0" bIns="0" rtlCol="0" anchor="ctr"/>
           <a:lstStyle/>
           <a:p>
-            <a:pPr algn="l" indent="0" marL="0">
-              <a:buNone/>
-            </a:pPr>
-            <a:r>
-              <a:rPr lang="en-US" sz="2800" b="1" dirty="0">
-                <a:solidFill>
-                  <a:srgbClr val="0E1C42"/>
-                </a:solidFill>
-                <a:latin typeface="Calibri" pitchFamily="34" charset="0"/>
-                <a:ea typeface="Calibri" pitchFamily="34" charset="-122"/>
-                <a:cs typeface="Calibri" pitchFamily="34" charset="-120"/>
-              </a:rPr>
-              <a:t>🔧 Fix-It Sentence — Answer Revealed</a:t>
-            </a:r>
-            <a:endParaRPr lang="en-US" sz="2800" dirty="0"/>
-          </a:p>
-        </p:txBody>
-      </p:sp>
-      <p:sp>
-        <p:nvSpPr>
-          <p:cNvPr id="3" name="Shape 1"/>
+            <a:pPr indent="0" marL="0">
+              <a:buNone/>
+            </a:pPr>
+            <a:r>
+              <a:rPr lang="en-US" sz="2200" b="1" dirty="0">
+                <a:solidFill>
+                  <a:srgbClr val="FFFFFF"/>
+                </a:solidFill>
+                <a:latin typeface="Calibri" pitchFamily="34" charset="0"/>
+                <a:ea typeface="Calibri" pitchFamily="34" charset="-122"/>
+                <a:cs typeface="Calibri" pitchFamily="34" charset="-120"/>
+              </a:rPr>
+              <a:t>✏️  Daily Oral Language</a:t>
+            </a:r>
+            <a:endParaRPr lang="en-US" sz="2200" dirty="0"/>
+          </a:p>
+        </p:txBody>
+      </p:sp>
+      <p:sp>
+        <p:nvSpPr>
+          <p:cNvPr id="4" name="Text 2"/>
           <p:cNvSpPr/>
           <p:nvPr/>
         </p:nvSpPr>
         <p:spPr>
           <a:xfrm>
             <a:off x="365760" y="749808"/>
-            <a:ext cx="8412480" cy="0"/>
-          </a:xfrm>
-          <a:prstGeom prst="line">
-            <a:avLst/>
-          </a:prstGeom>
-          <a:noFill/>
+            <a:ext cx="8229600" cy="237744"/>
+          </a:xfrm>
+          <a:prstGeom prst="rect">
+            <a:avLst/>
+          </a:prstGeom>
+          <a:noFill/>
+          <a:ln/>
+        </p:spPr>
+        <p:txBody>
+          <a:bodyPr wrap="square" lIns="0" tIns="0" rIns="0" bIns="0" rtlCol="0" anchor="ctr"/>
+          <a:lstStyle/>
+          <a:p>
+            <a:pPr indent="0" marL="0">
+              <a:buNone/>
+            </a:pPr>
+            <a:r>
+              <a:rPr lang="en-US" sz="1100" b="1" spc="100" kern="0" dirty="0">
+                <a:solidFill>
+                  <a:srgbClr val="55C8E8"/>
+                </a:solidFill>
+                <a:latin typeface="Calibri" pitchFamily="34" charset="0"/>
+                <a:ea typeface="Calibri" pitchFamily="34" charset="-122"/>
+                <a:cs typeface="Calibri" pitchFamily="34" charset="-120"/>
+              </a:rPr>
+              <a:t>NOW FIX THIS ONE</a:t>
+            </a:r>
+            <a:endParaRPr lang="en-US" sz="1100" dirty="0"/>
+          </a:p>
+        </p:txBody>
+      </p:sp>
+      <p:sp>
+        <p:nvSpPr>
+          <p:cNvPr id="5" name="Shape 3"/>
+          <p:cNvSpPr/>
+          <p:nvPr/>
+        </p:nvSpPr>
+        <p:spPr>
+          <a:xfrm>
+            <a:off x="365760" y="1024128"/>
+            <a:ext cx="8412480" cy="777240"/>
+          </a:xfrm>
+          <a:prstGeom prst="roundRect">
+            <a:avLst>
+              <a:gd name="adj" fmla="val 11765"/>
+            </a:avLst>
+          </a:prstGeom>
+          <a:solidFill>
+            <a:srgbClr val="FFFFFF"/>
+          </a:solidFill>
           <a:ln w="19050">
             <a:solidFill>
-              <a:srgbClr val="E67E22"/>
-            </a:solidFill>
-            <a:prstDash val="solid"/>
-          </a:ln>
-        </p:spPr>
-      </p:sp>
-      <p:sp>
-        <p:nvSpPr>
-          <p:cNvPr id="4" name="Shape 2"/>
-          <p:cNvSpPr/>
-          <p:nvPr/>
-        </p:nvSpPr>
-        <p:spPr>
-          <a:xfrm>
-            <a:off x="6492240" y="173736"/>
-            <a:ext cx="2286000" cy="502920"/>
-          </a:xfrm>
-          <a:prstGeom prst="roundRect">
-            <a:avLst>
-              <a:gd name="adj" fmla="val 21818"/>
-            </a:avLst>
-          </a:prstGeom>
-          <a:solidFill>
-            <a:srgbClr val="E67E22"/>
-          </a:solidFill>
-          <a:ln/>
-        </p:spPr>
-      </p:sp>
-      <p:sp>
-        <p:nvSpPr>
-          <p:cNvPr id="5" name="Text 3"/>
-          <p:cNvSpPr/>
-          <p:nvPr/>
-        </p:nvSpPr>
-        <p:spPr>
-          <a:xfrm>
-            <a:off x="6492240" y="173736"/>
-            <a:ext cx="2286000" cy="502920"/>
-          </a:xfrm>
-          <a:prstGeom prst="rect">
-            <a:avLst/>
-          </a:prstGeom>
-          <a:noFill/>
-          <a:ln/>
-        </p:spPr>
-        <p:txBody>
-          <a:bodyPr wrap="square" lIns="0" tIns="0" rIns="0" bIns="0" rtlCol="0" anchor="ctr"/>
-          <a:lstStyle/>
-          <a:p>
-            <a:pPr algn="ctr" indent="0" marL="0">
-              <a:buNone/>
-            </a:pPr>
-            <a:r>
-              <a:rPr lang="en-US" sz="1100" b="1" dirty="0">
-                <a:solidFill>
-                  <a:srgbClr val="0E1C42"/>
-                </a:solidFill>
-                <a:latin typeface="Calibri" pitchFamily="34" charset="0"/>
-                <a:ea typeface="Calibri" pitchFamily="34" charset="-122"/>
-                <a:cs typeface="Calibri" pitchFamily="34" charset="-120"/>
-              </a:rPr>
-              <a:t>CHAT PROMPT</a:t>
-            </a:r>
-            <a:endParaRPr lang="en-US" sz="1100" dirty="0"/>
-          </a:p>
-        </p:txBody>
-      </p:sp>
-      <p:sp>
-        <p:nvSpPr>
-          <p:cNvPr id="6" name="Shape 4"/>
-          <p:cNvSpPr/>
-          <p:nvPr/>
-        </p:nvSpPr>
-        <p:spPr>
-          <a:xfrm>
-            <a:off x="457200" y="1005840"/>
-            <a:ext cx="8229600" cy="640080"/>
-          </a:xfrm>
-          <a:prstGeom prst="roundRect">
-            <a:avLst>
-              <a:gd name="adj" fmla="val 14286"/>
-            </a:avLst>
-          </a:prstGeom>
-          <a:solidFill>
-            <a:srgbClr val="F8FAFC"/>
-          </a:solidFill>
-          <a:ln w="12700">
-            <a:solidFill>
-              <a:srgbClr val="C7922C"/>
+              <a:srgbClr val="55C8E8"/>
             </a:solidFill>
             <a:prstDash val="solid"/>
           </a:ln>
@@ -5241,14 +4573,14 @@
       </p:sp>
       <p:sp>
         <p:nvSpPr>
-          <p:cNvPr id="7" name="Text 5"/>
-          <p:cNvSpPr/>
-          <p:nvPr/>
-        </p:nvSpPr>
-        <p:spPr>
-          <a:xfrm>
-            <a:off x="640080" y="1115568"/>
-            <a:ext cx="7863840" cy="411480"/>
+          <p:cNvPr id="6" name="Text 4"/>
+          <p:cNvSpPr/>
+          <p:nvPr/>
+        </p:nvSpPr>
+        <p:spPr>
+          <a:xfrm>
+            <a:off x="594360" y="1152144"/>
+            <a:ext cx="7955280" cy="521208"/>
           </a:xfrm>
           <a:prstGeom prst="rect">
             <a:avLst/>
@@ -5264,7 +4596,7 @@
               <a:buNone/>
             </a:pPr>
             <a:r>
-              <a:rPr lang="en-US" sz="1800" i="1" dirty="0">
+              <a:rPr lang="en-US" sz="1700" dirty="0">
                 <a:solidFill>
                   <a:srgbClr val="1E293B"/>
                 </a:solidFill>
@@ -5274,74 +4606,30 @@
               </a:rPr>
               <a:t>after reading both texts i believe that courage is something every character we read about this year had to find inside themselves</a:t>
             </a:r>
-            <a:endParaRPr lang="en-US" sz="1800" dirty="0"/>
-          </a:p>
-        </p:txBody>
-      </p:sp>
-      <p:sp>
-        <p:nvSpPr>
-          <p:cNvPr id="8" name="Text 6"/>
-          <p:cNvSpPr/>
-          <p:nvPr/>
-        </p:nvSpPr>
-        <p:spPr>
-          <a:xfrm>
-            <a:off x="457200" y="1737360"/>
-            <a:ext cx="8046720" cy="292608"/>
-          </a:xfrm>
-          <a:prstGeom prst="rect">
-            <a:avLst/>
-          </a:prstGeom>
-          <a:noFill/>
-          <a:ln/>
-        </p:spPr>
-        <p:txBody>
-          <a:bodyPr wrap="square" lIns="0" tIns="0" rIns="0" bIns="0" rtlCol="0" anchor="ctr"/>
-          <a:lstStyle/>
-          <a:p>
-            <a:pPr indent="0" marL="0">
-              <a:buNone/>
-            </a:pPr>
-            <a:r>
-              <a:rPr lang="en-US" sz="1100" b="1" spc="200" kern="0" dirty="0">
-                <a:solidFill>
-                  <a:srgbClr val="34B76F"/>
-                </a:solidFill>
-                <a:latin typeface="Calibri" pitchFamily="34" charset="0"/>
-                <a:ea typeface="Calibri" pitchFamily="34" charset="-122"/>
-                <a:cs typeface="Calibri" pitchFamily="34" charset="-120"/>
-              </a:rPr>
-              <a:t>CORRECTED</a:t>
-            </a:r>
-            <a:endParaRPr lang="en-US" sz="1100" dirty="0"/>
-          </a:p>
-        </p:txBody>
-      </p:sp>
-      <p:sp>
-        <p:nvSpPr>
-          <p:cNvPr id="9" name="Shape 7"/>
-          <p:cNvSpPr/>
-          <p:nvPr/>
-        </p:nvSpPr>
-        <p:spPr>
-          <a:xfrm>
-            <a:off x="457200" y="2057400"/>
-            <a:ext cx="8229600" cy="640080"/>
+            <a:endParaRPr lang="en-US" sz="1700" dirty="0"/>
+          </a:p>
+        </p:txBody>
+      </p:sp>
+      <p:sp>
+        <p:nvSpPr>
+          <p:cNvPr id="7" name="Shape 5"/>
+          <p:cNvSpPr/>
+          <p:nvPr/>
+        </p:nvSpPr>
+        <p:spPr>
+          <a:xfrm>
+            <a:off x="365760" y="2743200"/>
+            <a:ext cx="8412480" cy="1417320"/>
           </a:xfrm>
           <a:prstGeom prst="roundRect">
             <a:avLst>
-              <a:gd name="adj" fmla="val 14286"/>
+              <a:gd name="adj" fmla="val 6452"/>
             </a:avLst>
           </a:prstGeom>
           <a:solidFill>
             <a:srgbClr val="E8F8EF"/>
           </a:solidFill>
-          <a:ln w="12700">
-            <a:solidFill>
-              <a:srgbClr val="34B76F"/>
-            </a:solidFill>
-            <a:prstDash val="solid"/>
-          </a:ln>
+          <a:ln/>
           <a:effectLst>
             <a:outerShdw sx="100000" sy="100000" kx="0" ky="0" algn="bl" rotWithShape="0" blurRad="101600" dist="38100" dir="2700000">
               <a:srgbClr val="000000">
@@ -5353,14 +4641,98 @@
       </p:sp>
       <p:sp>
         <p:nvSpPr>
+          <p:cNvPr id="8" name="Text 6"/>
+          <p:cNvSpPr/>
+          <p:nvPr/>
+        </p:nvSpPr>
+        <p:spPr>
+          <a:xfrm>
+            <a:off x="566928" y="2816352"/>
+            <a:ext cx="8229600" cy="237744"/>
+          </a:xfrm>
+          <a:prstGeom prst="rect">
+            <a:avLst/>
+          </a:prstGeom>
+          <a:noFill/>
+          <a:ln/>
+        </p:spPr>
+        <p:txBody>
+          <a:bodyPr wrap="square" lIns="0" tIns="0" rIns="0" bIns="0" rtlCol="0" anchor="ctr"/>
+          <a:lstStyle/>
+          <a:p>
+            <a:pPr indent="0" marL="0">
+              <a:buNone/>
+            </a:pPr>
+            <a:r>
+              <a:rPr lang="en-US" sz="1100" b="1" spc="100" kern="0" dirty="0">
+                <a:solidFill>
+                  <a:srgbClr val="34B76F"/>
+                </a:solidFill>
+                <a:latin typeface="Calibri" pitchFamily="34" charset="0"/>
+                <a:ea typeface="Calibri" pitchFamily="34" charset="-122"/>
+                <a:cs typeface="Calibri" pitchFamily="34" charset="-120"/>
+              </a:rPr>
+              <a:t>✅  CORRECTED</a:t>
+            </a:r>
+            <a:endParaRPr lang="en-US" sz="1100" dirty="0"/>
+          </a:p>
+        </p:txBody>
+      </p:sp>
+      <p:sp>
+        <p:nvSpPr>
+          <p:cNvPr id="9" name="Text 7"/>
+          <p:cNvSpPr/>
+          <p:nvPr/>
+        </p:nvSpPr>
+        <p:spPr>
+          <a:xfrm>
+            <a:off x="566928" y="3072384"/>
+            <a:ext cx="8010144" cy="685800"/>
+          </a:xfrm>
+          <a:prstGeom prst="rect">
+            <a:avLst/>
+          </a:prstGeom>
+          <a:noFill/>
+          <a:ln/>
+        </p:spPr>
+        <p:txBody>
+          <a:bodyPr wrap="square" lIns="0" tIns="0" rIns="0" bIns="0" rtlCol="0" anchor="ctr"/>
+          <a:lstStyle/>
+          <a:p>
+            <a:pPr indent="0" marL="0">
+              <a:buNone/>
+            </a:pPr>
+            <a:r>
+              <a:rPr lang="en-US" sz="1400" i="1" dirty="0">
+                <a:solidFill>
+                  <a:srgbClr val="1E293B"/>
+                </a:solidFill>
+                <a:latin typeface="Calibri" pitchFamily="34" charset="0"/>
+                <a:ea typeface="Calibri" pitchFamily="34" charset="-122"/>
+                <a:cs typeface="Calibri" pitchFamily="34" charset="-120"/>
+              </a:rPr>
+              <a:t>Corrected: After reading both texts, I believe that courage is something every character we read about this year had to find inside themselves.</a:t>
+            </a:r>
+            <a:endParaRPr lang="en-US" sz="1400" dirty="0"/>
+          </a:p>
+          <a:p>
+            <a:pPr indent="0" marL="0">
+              <a:buNone/>
+            </a:pPr>
+            <a:endParaRPr lang="en-US" sz="1400" dirty="0"/>
+          </a:p>
+        </p:txBody>
+      </p:sp>
+      <p:sp>
+        <p:nvSpPr>
           <p:cNvPr id="10" name="Text 8"/>
           <p:cNvSpPr/>
           <p:nvPr/>
         </p:nvSpPr>
         <p:spPr>
           <a:xfrm>
-            <a:off x="640080" y="2167128"/>
-            <a:ext cx="7863840" cy="411480"/>
+            <a:off x="566928" y="3767328"/>
+            <a:ext cx="8010144" cy="320040"/>
           </a:xfrm>
           <a:prstGeom prst="rect">
             <a:avLst/>
@@ -5376,46 +4748,7 @@
               <a:buNone/>
             </a:pPr>
             <a:r>
-              <a:rPr lang="en-US" sz="1800" i="1" dirty="0">
-                <a:solidFill>
-                  <a:srgbClr val="34B76F"/>
-                </a:solidFill>
-                <a:latin typeface="Calibri" pitchFamily="34" charset="0"/>
-                <a:ea typeface="Calibri" pitchFamily="34" charset="-122"/>
-                <a:cs typeface="Calibri" pitchFamily="34" charset="-120"/>
-              </a:rPr>
-              <a:t>After reading both texts, I believe that courage is something every character we read about this year had to find inside themselves.</a:t>
-            </a:r>
-            <a:endParaRPr lang="en-US" sz="1800" dirty="0"/>
-          </a:p>
-        </p:txBody>
-      </p:sp>
-      <p:sp>
-        <p:nvSpPr>
-          <p:cNvPr id="11" name="Text 9"/>
-          <p:cNvSpPr/>
-          <p:nvPr/>
-        </p:nvSpPr>
-        <p:spPr>
-          <a:xfrm>
-            <a:off x="457200" y="2834640"/>
-            <a:ext cx="8046720" cy="292608"/>
-          </a:xfrm>
-          <a:prstGeom prst="rect">
-            <a:avLst/>
-          </a:prstGeom>
-          <a:noFill/>
-          <a:ln/>
-        </p:spPr>
-        <p:txBody>
-          <a:bodyPr wrap="square" lIns="0" tIns="0" rIns="0" bIns="0" rtlCol="0" anchor="ctr"/>
-          <a:lstStyle/>
-          <a:p>
-            <a:pPr indent="0" marL="0">
-              <a:buNone/>
-            </a:pPr>
-            <a:r>
-              <a:rPr lang="en-US" sz="1100" b="1" spc="200" kern="0" dirty="0">
+              <a:rPr lang="en-US" sz="1200" dirty="0">
                 <a:solidFill>
                   <a:srgbClr val="64748B"/>
                 </a:solidFill>
@@ -5423,48 +4756,9 @@
                 <a:ea typeface="Calibri" pitchFamily="34" charset="-122"/>
                 <a:cs typeface="Calibri" pitchFamily="34" charset="-120"/>
               </a:rPr>
-              <a:t>WHY</a:t>
-            </a:r>
-            <a:endParaRPr lang="en-US" sz="1100" dirty="0"/>
-          </a:p>
-        </p:txBody>
-      </p:sp>
-      <p:sp>
-        <p:nvSpPr>
-          <p:cNvPr id="12" name="Text 10"/>
-          <p:cNvSpPr/>
-          <p:nvPr/>
-        </p:nvSpPr>
-        <p:spPr>
-          <a:xfrm>
-            <a:off x="640080" y="3108960"/>
-            <a:ext cx="7863840" cy="502920"/>
-          </a:xfrm>
-          <a:prstGeom prst="rect">
-            <a:avLst/>
-          </a:prstGeom>
-          <a:noFill/>
-          <a:ln/>
-        </p:spPr>
-        <p:txBody>
-          <a:bodyPr wrap="square" lIns="0" tIns="0" rIns="0" bIns="0" rtlCol="0" anchor="ctr"/>
-          <a:lstStyle/>
-          <a:p>
-            <a:pPr indent="0" marL="0">
-              <a:buNone/>
-            </a:pPr>
-            <a:r>
-              <a:rPr lang="en-US" sz="1300" i="1" dirty="0">
-                <a:solidFill>
-                  <a:srgbClr val="64748B"/>
-                </a:solidFill>
-                <a:latin typeface="Calibri" pitchFamily="34" charset="0"/>
-                <a:ea typeface="Calibri" pitchFamily="34" charset="-122"/>
-                <a:cs typeface="Calibri" pitchFamily="34" charset="-120"/>
-              </a:rPr>
               <a:t>After reading both texts begins the dependent clause; comma after texts; I is always capitalized; period ends.</a:t>
             </a:r>
-            <a:endParaRPr lang="en-US" sz="1300" dirty="0"/>
+            <a:endParaRPr lang="en-US" sz="1200" dirty="0"/>
           </a:p>
         </p:txBody>
       </p:sp>

</xml_diff>